<commit_message>
fix(deck): slide 19 names the features, not our shorthand
"Staffing a rota" means nothing to someone outside the team, and every
title assumed the reader already knew which Dagar feature was being
withheld. A judge should not have to ask what the mentor offer is.

Each title now names the missing feature in the words a stranger would
use, and each body says what it would do before saying why it is not
there. The WhatsApp card leads with what parents already get, so it does
not read as parents being ignored.

Also fixes a factual error that was sitting on the slide: it claimed no
badges. Dagar has badges and 103 have been awarded. The real position is
no leaderboard and no lives, while keeping streaks and badges, because
those reward turning up rather than ranking one child against another.

Co-Authored-By: Claude Opus 5 <noreply@anthropic.com>
</commit_message>
<xml_diff>
--- a/docs/deck/Dagar-Pitch-Deck.pptx
+++ b/docs/deck/Dagar-Pitch-Deck.pptx
@@ -17822,8 +17822,8 @@
         </p:nvSpPr>
         <p:spPr>
           <a:xfrm>
-            <a:off x="566928" y="1938528"/>
-            <a:ext cx="5391759" cy="1152144"/>
+            <a:off x="566928" y="1901952"/>
+            <a:ext cx="5391759" cy="1335024"/>
           </a:xfrm>
           <a:prstGeom prst="roundRect">
             <a:avLst>
@@ -17870,8 +17870,8 @@
         </p:nvSpPr>
         <p:spPr>
           <a:xfrm>
-            <a:off x="566928" y="2103120"/>
-            <a:ext cx="41148" cy="822960"/>
+            <a:off x="566928" y="2066544"/>
+            <a:ext cx="41148" cy="1005840"/>
           </a:xfrm>
           <a:prstGeom prst="rect">
             <a:avLst/>
@@ -17914,8 +17914,8 @@
         </p:nvSpPr>
         <p:spPr>
           <a:xfrm>
-            <a:off x="822960" y="2121408"/>
-            <a:ext cx="4934559" cy="822960"/>
+            <a:off x="822960" y="2084832"/>
+            <a:ext cx="4934559" cy="1005840"/>
           </a:xfrm>
           <a:prstGeom prst="rect">
             <a:avLst/>
@@ -17940,13 +17940,13 @@
               </a:spcAft>
             </a:pPr>
             <a:r>
-              <a:rPr sz="1200" b="1" i="0">
+              <a:rPr sz="1150" b="1" i="0">
                 <a:solidFill>
                   <a:srgbClr val="1A2733"/>
                 </a:solidFill>
                 <a:latin typeface="Arial"/>
               </a:rPr>
-              <a:t>No leaderboards, hearts, lives or XP</a:t>
+              <a:t>No leaderboard ranking children against each other</a:t>
             </a:r>
           </a:p>
           <a:p>
@@ -17962,13 +17962,13 @@
               </a:spcAft>
             </a:pPr>
             <a:r>
-              <a:rPr sz="1000" b="0" i="0">
+              <a:rPr sz="950" b="0" i="0">
                 <a:solidFill>
                   <a:srgbClr val="3F4A57"/>
                 </a:solidFill>
                 <a:latin typeface="Arial"/>
               </a:rPr>
-              <a:t>Every one of those mechanics inverts for a learner who is already behind. Losing a life for a wrong answer punishes exactly the child who needed another try.</a:t>
+              <a:t>Many learning apps show a public table of who is ahead, and take away a life when an answer is wrong. Both land hardest on the child who is already behind. Dagar has streaks and badges, which reward turning up, and nothing that compares one learner to another.</a:t>
             </a:r>
           </a:p>
         </p:txBody>
@@ -17981,8 +17981,8 @@
         </p:nvSpPr>
         <p:spPr>
           <a:xfrm>
-            <a:off x="6233007" y="1938528"/>
-            <a:ext cx="5391759" cy="1152144"/>
+            <a:off x="6233007" y="1901952"/>
+            <a:ext cx="5391759" cy="1335024"/>
           </a:xfrm>
           <a:prstGeom prst="roundRect">
             <a:avLst>
@@ -18029,8 +18029,8 @@
         </p:nvSpPr>
         <p:spPr>
           <a:xfrm>
-            <a:off x="6233007" y="2103120"/>
-            <a:ext cx="41148" cy="822960"/>
+            <a:off x="6233007" y="2066544"/>
+            <a:ext cx="41148" cy="1005840"/>
           </a:xfrm>
           <a:prstGeom prst="rect">
             <a:avLst/>
@@ -18073,8 +18073,8 @@
         </p:nvSpPr>
         <p:spPr>
           <a:xfrm>
-            <a:off x="6489039" y="2121408"/>
-            <a:ext cx="4934559" cy="822960"/>
+            <a:off x="6489039" y="2084832"/>
+            <a:ext cx="4934559" cy="1005840"/>
           </a:xfrm>
           <a:prstGeom prst="rect">
             <a:avLst/>
@@ -18099,13 +18099,13 @@
               </a:spcAft>
             </a:pPr>
             <a:r>
-              <a:rPr sz="1200" b="1" i="0">
+              <a:rPr sz="1150" b="1" i="0">
                 <a:solidFill>
                   <a:srgbClr val="1A2733"/>
                 </a:solidFill>
                 <a:latin typeface="Arial"/>
               </a:rPr>
-              <a:t>No mentor service behind the offer</a:t>
+              <a:t>No real teacher yet behind the offer of human help</a:t>
             </a:r>
           </a:p>
           <a:p>
@@ -18121,13 +18121,13 @@
               </a:spcAft>
             </a:pPr>
             <a:r>
-              <a:rPr sz="1000" b="0" i="0">
+              <a:rPr sz="950" b="0" i="0">
                 <a:solidFill>
                   <a:srgbClr val="3F4A57"/>
                 </a:solidFill>
                 <a:latin typeface="Arial"/>
               </a:rPr>
-              <a:t>Staffing a rota before knowing how often learners ask would be building on an assumption. 34 offers and 1 acceptance is the beginning of the answer.</a:t>
+              <a:t>When a learner keeps getting stuck, Dagar offers to connect them with a person. Today that request is recorded and nobody is employed to answer it. 34 offers made, 1 accepted so far. That number is what we wanted before paying anyone to be on call.</a:t>
             </a:r>
           </a:p>
         </p:txBody>
@@ -18140,8 +18140,8 @@
         </p:nvSpPr>
         <p:spPr>
           <a:xfrm>
-            <a:off x="566928" y="3236976"/>
-            <a:ext cx="5391759" cy="1152144"/>
+            <a:off x="566928" y="3364992"/>
+            <a:ext cx="5391759" cy="1335024"/>
           </a:xfrm>
           <a:prstGeom prst="roundRect">
             <a:avLst>
@@ -18188,8 +18188,8 @@
         </p:nvSpPr>
         <p:spPr>
           <a:xfrm>
-            <a:off x="566928" y="3401568"/>
-            <a:ext cx="41148" cy="822960"/>
+            <a:off x="566928" y="3529584"/>
+            <a:ext cx="41148" cy="1005840"/>
           </a:xfrm>
           <a:prstGeom prst="rect">
             <a:avLst/>
@@ -18232,8 +18232,8 @@
         </p:nvSpPr>
         <p:spPr>
           <a:xfrm>
-            <a:off x="822960" y="3419856"/>
-            <a:ext cx="4934559" cy="822960"/>
+            <a:off x="822960" y="3547872"/>
+            <a:ext cx="4934559" cy="1005840"/>
           </a:xfrm>
           <a:prstGeom prst="rect">
             <a:avLst/>
@@ -18258,13 +18258,13 @@
               </a:spcAft>
             </a:pPr>
             <a:r>
-              <a:rPr sz="1200" b="1" i="0">
+              <a:rPr sz="1150" b="1" i="0">
                 <a:solidFill>
                   <a:srgbClr val="1A2733"/>
                 </a:solidFill>
                 <a:latin typeface="Arial"/>
               </a:rPr>
-              <a:t>No automatic WhatsApp delivery</a:t>
+              <a:t>No weekly progress report sent to a parent on WhatsApp</a:t>
             </a:r>
           </a:p>
           <a:p>
@@ -18280,13 +18280,13 @@
               </a:spcAft>
             </a:pPr>
             <a:r>
-              <a:rPr sz="1000" b="0" i="0">
+              <a:rPr sz="950" b="0" i="0">
                 <a:solidFill>
                   <a:srgbClr val="3F4A57"/>
                 </a:solidFill>
                 <a:latin typeface="Arial"/>
               </a:rPr>
-              <a:t>It needs business verification and an opt-in from the parent's own handset. The link already lets them see progress with no account at all.</a:t>
+              <a:t>Parents are not left out: they open a private link any time and see the last seven days, with no account, no app and no password. What is missing is Dagar sending it to them unprompted, which needs Meta business approval and an opt-in from the parent's own phone.</a:t>
             </a:r>
           </a:p>
         </p:txBody>
@@ -18299,8 +18299,8 @@
         </p:nvSpPr>
         <p:spPr>
           <a:xfrm>
-            <a:off x="6233007" y="3236976"/>
-            <a:ext cx="5391759" cy="1152144"/>
+            <a:off x="6233007" y="3364992"/>
+            <a:ext cx="5391759" cy="1335024"/>
           </a:xfrm>
           <a:prstGeom prst="roundRect">
             <a:avLst>
@@ -18347,8 +18347,8 @@
         </p:nvSpPr>
         <p:spPr>
           <a:xfrm>
-            <a:off x="6233007" y="3401568"/>
-            <a:ext cx="41148" cy="822960"/>
+            <a:off x="6233007" y="3529584"/>
+            <a:ext cx="41148" cy="1005840"/>
           </a:xfrm>
           <a:prstGeom prst="rect">
             <a:avLst/>
@@ -18391,8 +18391,8 @@
         </p:nvSpPr>
         <p:spPr>
           <a:xfrm>
-            <a:off x="6489039" y="3419856"/>
-            <a:ext cx="4934559" cy="822960"/>
+            <a:off x="6489039" y="3547872"/>
+            <a:ext cx="4934559" cy="1005840"/>
           </a:xfrm>
           <a:prstGeom prst="rect">
             <a:avLst/>
@@ -18417,13 +18417,13 @@
               </a:spcAft>
             </a:pPr>
             <a:r>
-              <a:rPr sz="1200" b="1" i="0">
+              <a:rPr sz="1150" b="1" i="0">
                 <a:solidFill>
                   <a:srgbClr val="1A2733"/>
                 </a:solidFill>
                 <a:latin typeface="Arial"/>
               </a:rPr>
-              <a:t>No offline mode</a:t>
+              <a:t>No lessons that keep working without internet</a:t>
             </a:r>
           </a:p>
           <a:p>
@@ -18439,13 +18439,13 @@
               </a:spcAft>
             </a:pPr>
             <a:r>
-              <a:rPr sz="1000" b="0" i="0">
+              <a:rPr sz="950" b="0" i="0">
                 <a:solidFill>
                   <a:srgbClr val="3F4A57"/>
                 </a:solidFill>
                 <a:latin typeface="Arial"/>
               </a:rPr>
-              <a:t>Lessons need a connection. Worth building, and not before we knew which lessons learners actually return to. Guessing that would have cost days of caching the wrong things.</a:t>
+              <a:t>Nothing is saved to the phone for use offline. It matters for these learners and it is on the roadmap. We did not want to guess which lessons to store before we could see which ones learners actually come back to.</a:t>
             </a:r>
           </a:p>
         </p:txBody>
@@ -18458,7 +18458,7 @@
         </p:nvSpPr>
         <p:spPr>
           <a:xfrm>
-            <a:off x="566928" y="4791456"/>
+            <a:off x="566928" y="5120640"/>
             <a:ext cx="11057839" cy="1078992"/>
           </a:xfrm>
           <a:prstGeom prst="roundRect">
@@ -18506,7 +18506,7 @@
         </p:nvSpPr>
         <p:spPr>
           <a:xfrm>
-            <a:off x="566928" y="4974336"/>
+            <a:off x="566928" y="5303520"/>
             <a:ext cx="54864" cy="676656"/>
           </a:xfrm>
           <a:prstGeom prst="rect">
@@ -18550,7 +18550,7 @@
         </p:nvSpPr>
         <p:spPr>
           <a:xfrm>
-            <a:off x="877824" y="4937760"/>
+            <a:off x="877824" y="5266944"/>
             <a:ext cx="10417759" cy="822960"/>
           </a:xfrm>
           <a:prstGeom prst="rect">
@@ -18601,7 +18601,7 @@
                 </a:solidFill>
                 <a:latin typeface="Arial"/>
               </a:rPr>
-              <a:t>Do not build the expensive version until the cheap one has answered whether anyone wants it. The mentor offer is running instead of a rota, the parent link is working instead of a WhatsApp pipeline, and nothing is cached offline until we know which lessons learners come back to. The fourth is different: no leaderboards or lives is a design principle, and it is not for trading.</a:t>
+              <a:t>Do not build the expensive version until the cheap one has told you whether anyone wants it. We are counting how many learners ask for a human before we pay anyone to be one. Parents already have a link that works, so the WhatsApp message can wait for approval. Nothing is stored offline until we know what is worth storing. The fourth is not a wait-and-see: no leaderboard is a decision about what this product is for, and it is not for trading.</a:t>
             </a:r>
           </a:p>
         </p:txBody>

</xml_diff>

<commit_message>
fix(deck): the pricing tiers become a four-column table
They were one dense card: four prices in five lines of prose, which is
the wrong shape for the thing a room reads first on a monetisation
slide. Each tier now gets a column with the price set large in its own
header block, and what it includes underneath.

The three arguments that were competing with them for space are now a
row below: the ₹370 floor with the thin ₹80 margin stated, why
institutions rather than families, and why advertising is closed to us
under the DPDP Act.

Also fixes a stale cross-reference. Slide 5 pointed at "slide 22" for
the full tiers, which was correct before the eval and long-term roadmap
slides went in and moved monetisation to 24.

Co-Authored-By: Claude Opus 5 <noreply@anthropic.com>
</commit_message>
<xml_diff>
--- a/docs/deck/Dagar-Pitch-Deck.pptx
+++ b/docs/deck/Dagar-Pitch-Deck.pptx
@@ -30767,467 +30767,7 @@
         <p:spPr>
           <a:xfrm>
             <a:off x="566928" y="1883664"/>
-            <a:ext cx="2065629" cy="822960"/>
-          </a:xfrm>
-          <a:prstGeom prst="roundRect">
-            <a:avLst>
-              <a:gd name="adj" fmla="val 6000"/>
-            </a:avLst>
-          </a:prstGeom>
-          <a:solidFill>
-            <a:srgbClr val="F0FDFA"/>
-          </a:solidFill>
-          <a:ln w="12700">
-            <a:solidFill>
-              <a:srgbClr val="D8DEE4"/>
-            </a:solidFill>
-          </a:ln>
-          <a:effectLst/>
-        </p:spPr>
-        <p:style>
-          <a:lnRef idx="1">
-            <a:schemeClr val="accent1"/>
-          </a:lnRef>
-          <a:fillRef idx="3">
-            <a:schemeClr val="accent1"/>
-          </a:fillRef>
-          <a:effectRef idx="2">
-            <a:schemeClr val="accent1"/>
-          </a:effectRef>
-          <a:fontRef idx="minor">
-            <a:schemeClr val="lt1"/>
-          </a:fontRef>
-        </p:style>
-        <p:txBody>
-          <a:bodyPr rtlCol="0" anchor="ctr"/>
-          <a:lstStyle/>
-          <a:p>
-            <a:pPr algn="ctr"/>
-          </a:p>
-        </p:txBody>
-      </p:sp>
-      <p:sp>
-        <p:nvSpPr>
-          <p:cNvPr id="9" name="TextBox 8"/>
-          <p:cNvSpPr txBox="1"/>
-          <p:nvPr/>
-        </p:nvSpPr>
-        <p:spPr>
-          <a:xfrm>
-            <a:off x="804672" y="2084832"/>
-            <a:ext cx="1608429" cy="457200"/>
-          </a:xfrm>
-          <a:prstGeom prst="rect">
-            <a:avLst/>
-          </a:prstGeom>
-          <a:noFill/>
-        </p:spPr>
-        <p:txBody>
-          <a:bodyPr wrap="square" lIns="0" rIns="0" tIns="0" bIns="0" anchor="t">
-            <a:spAutoFit/>
-          </a:bodyPr>
-          <a:lstStyle/>
-          <a:p>
-            <a:pPr algn="l">
-              <a:lnSpc>
-                <a:spcPct val="100000"/>
-              </a:lnSpc>
-              <a:spcBef>
-                <a:spcPts val="0"/>
-              </a:spcBef>
-              <a:spcAft>
-                <a:spcPts val="300"/>
-              </a:spcAft>
-            </a:pPr>
-            <a:r>
-              <a:rPr sz="3000" b="1" i="0">
-                <a:solidFill>
-                  <a:srgbClr val="0F766E"/>
-                </a:solidFill>
-                <a:latin typeface="Arial"/>
-              </a:rPr>
-              <a:t>₹0</a:t>
-            </a:r>
-          </a:p>
-          <a:p>
-            <a:pPr algn="l">
-              <a:lnSpc>
-                <a:spcPct val="115000"/>
-              </a:lnSpc>
-              <a:spcBef>
-                <a:spcPts val="0"/>
-              </a:spcBef>
-              <a:spcAft>
-                <a:spcPts val="300"/>
-              </a:spcAft>
-            </a:pPr>
-            <a:r>
-              <a:rPr sz="1100" b="1" i="0">
-                <a:solidFill>
-                  <a:srgbClr val="1A2733"/>
-                </a:solidFill>
-                <a:latin typeface="Arial"/>
-              </a:rPr>
-              <a:t>for the learning loop</a:t>
-            </a:r>
-          </a:p>
-        </p:txBody>
-      </p:sp>
-      <p:sp>
-        <p:nvSpPr>
-          <p:cNvPr id="10" name="Rounded Rectangle 9"/>
-          <p:cNvSpPr/>
-          <p:nvPr/>
-        </p:nvSpPr>
-        <p:spPr>
-          <a:xfrm>
-            <a:off x="2815437" y="1883664"/>
-            <a:ext cx="2065629" cy="822960"/>
-          </a:xfrm>
-          <a:prstGeom prst="roundRect">
-            <a:avLst>
-              <a:gd name="adj" fmla="val 6000"/>
-            </a:avLst>
-          </a:prstGeom>
-          <a:solidFill>
-            <a:srgbClr val="F0FDFA"/>
-          </a:solidFill>
-          <a:ln w="12700">
-            <a:solidFill>
-              <a:srgbClr val="D8DEE4"/>
-            </a:solidFill>
-          </a:ln>
-          <a:effectLst/>
-        </p:spPr>
-        <p:style>
-          <a:lnRef idx="1">
-            <a:schemeClr val="accent1"/>
-          </a:lnRef>
-          <a:fillRef idx="3">
-            <a:schemeClr val="accent1"/>
-          </a:fillRef>
-          <a:effectRef idx="2">
-            <a:schemeClr val="accent1"/>
-          </a:effectRef>
-          <a:fontRef idx="minor">
-            <a:schemeClr val="lt1"/>
-          </a:fontRef>
-        </p:style>
-        <p:txBody>
-          <a:bodyPr rtlCol="0" anchor="ctr"/>
-          <a:lstStyle/>
-          <a:p>
-            <a:pPr algn="ctr"/>
-          </a:p>
-        </p:txBody>
-      </p:sp>
-      <p:sp>
-        <p:nvSpPr>
-          <p:cNvPr id="11" name="TextBox 10"/>
-          <p:cNvSpPr txBox="1"/>
-          <p:nvPr/>
-        </p:nvSpPr>
-        <p:spPr>
-          <a:xfrm>
-            <a:off x="3053181" y="2084832"/>
-            <a:ext cx="1608429" cy="457200"/>
-          </a:xfrm>
-          <a:prstGeom prst="rect">
-            <a:avLst/>
-          </a:prstGeom>
-          <a:noFill/>
-        </p:spPr>
-        <p:txBody>
-          <a:bodyPr wrap="square" lIns="0" rIns="0" tIns="0" bIns="0" anchor="t">
-            <a:spAutoFit/>
-          </a:bodyPr>
-          <a:lstStyle/>
-          <a:p>
-            <a:pPr algn="l">
-              <a:lnSpc>
-                <a:spcPct val="100000"/>
-              </a:lnSpc>
-              <a:spcBef>
-                <a:spcPts val="0"/>
-              </a:spcBef>
-              <a:spcAft>
-                <a:spcPts val="300"/>
-              </a:spcAft>
-            </a:pPr>
-            <a:r>
-              <a:rPr sz="3000" b="1" i="0">
-                <a:solidFill>
-                  <a:srgbClr val="0F766E"/>
-                </a:solidFill>
-                <a:latin typeface="Arial"/>
-              </a:rPr>
-              <a:t>₹370</a:t>
-            </a:r>
-          </a:p>
-          <a:p>
-            <a:pPr algn="l">
-              <a:lnSpc>
-                <a:spcPct val="115000"/>
-              </a:lnSpc>
-              <a:spcBef>
-                <a:spcPts val="0"/>
-              </a:spcBef>
-              <a:spcAft>
-                <a:spcPts val="300"/>
-              </a:spcAft>
-            </a:pPr>
-            <a:r>
-              <a:rPr sz="1100" b="1" i="0">
-                <a:solidFill>
-                  <a:srgbClr val="1A2733"/>
-                </a:solidFill>
-                <a:latin typeface="Arial"/>
-              </a:rPr>
-              <a:t>modelled cost floor</a:t>
-            </a:r>
-          </a:p>
-        </p:txBody>
-      </p:sp>
-      <p:sp>
-        <p:nvSpPr>
-          <p:cNvPr id="12" name="Rounded Rectangle 11"/>
-          <p:cNvSpPr/>
-          <p:nvPr/>
-        </p:nvSpPr>
-        <p:spPr>
-          <a:xfrm>
-            <a:off x="5063947" y="1883664"/>
-            <a:ext cx="2065629" cy="822960"/>
-          </a:xfrm>
-          <a:prstGeom prst="roundRect">
-            <a:avLst>
-              <a:gd name="adj" fmla="val 6000"/>
-            </a:avLst>
-          </a:prstGeom>
-          <a:solidFill>
-            <a:srgbClr val="F0FDFA"/>
-          </a:solidFill>
-          <a:ln w="12700">
-            <a:solidFill>
-              <a:srgbClr val="D8DEE4"/>
-            </a:solidFill>
-          </a:ln>
-          <a:effectLst/>
-        </p:spPr>
-        <p:style>
-          <a:lnRef idx="1">
-            <a:schemeClr val="accent1"/>
-          </a:lnRef>
-          <a:fillRef idx="3">
-            <a:schemeClr val="accent1"/>
-          </a:fillRef>
-          <a:effectRef idx="2">
-            <a:schemeClr val="accent1"/>
-          </a:effectRef>
-          <a:fontRef idx="minor">
-            <a:schemeClr val="lt1"/>
-          </a:fontRef>
-        </p:style>
-        <p:txBody>
-          <a:bodyPr rtlCol="0" anchor="ctr"/>
-          <a:lstStyle/>
-          <a:p>
-            <a:pPr algn="ctr"/>
-          </a:p>
-        </p:txBody>
-      </p:sp>
-      <p:sp>
-        <p:nvSpPr>
-          <p:cNvPr id="13" name="TextBox 12"/>
-          <p:cNvSpPr txBox="1"/>
-          <p:nvPr/>
-        </p:nvSpPr>
-        <p:spPr>
-          <a:xfrm>
-            <a:off x="5301691" y="2084832"/>
-            <a:ext cx="1608429" cy="457200"/>
-          </a:xfrm>
-          <a:prstGeom prst="rect">
-            <a:avLst/>
-          </a:prstGeom>
-          <a:noFill/>
-        </p:spPr>
-        <p:txBody>
-          <a:bodyPr wrap="square" lIns="0" rIns="0" tIns="0" bIns="0" anchor="t">
-            <a:spAutoFit/>
-          </a:bodyPr>
-          <a:lstStyle/>
-          <a:p>
-            <a:pPr algn="l">
-              <a:lnSpc>
-                <a:spcPct val="100000"/>
-              </a:lnSpc>
-              <a:spcBef>
-                <a:spcPts val="0"/>
-              </a:spcBef>
-              <a:spcAft>
-                <a:spcPts val="300"/>
-              </a:spcAft>
-            </a:pPr>
-            <a:r>
-              <a:rPr sz="3000" b="1" i="0">
-                <a:solidFill>
-                  <a:srgbClr val="0F766E"/>
-                </a:solidFill>
-                <a:latin typeface="Arial"/>
-              </a:rPr>
-              <a:t>₹450</a:t>
-            </a:r>
-          </a:p>
-          <a:p>
-            <a:pPr algn="l">
-              <a:lnSpc>
-                <a:spcPct val="115000"/>
-              </a:lnSpc>
-              <a:spcBef>
-                <a:spcPts val="0"/>
-              </a:spcBef>
-              <a:spcAft>
-                <a:spcPts val="300"/>
-              </a:spcAft>
-            </a:pPr>
-            <a:r>
-              <a:rPr sz="1100" b="1" i="0">
-                <a:solidFill>
-                  <a:srgbClr val="1A2733"/>
-                </a:solidFill>
-                <a:latin typeface="Arial"/>
-              </a:rPr>
-              <a:t>institutional, per year</a:t>
-            </a:r>
-          </a:p>
-        </p:txBody>
-      </p:sp>
-      <p:sp>
-        <p:nvSpPr>
-          <p:cNvPr id="14" name="Rounded Rectangle 13"/>
-          <p:cNvSpPr/>
-          <p:nvPr/>
-        </p:nvSpPr>
-        <p:spPr>
-          <a:xfrm>
-            <a:off x="7312456" y="1883664"/>
-            <a:ext cx="2065629" cy="822960"/>
-          </a:xfrm>
-          <a:prstGeom prst="roundRect">
-            <a:avLst>
-              <a:gd name="adj" fmla="val 6000"/>
-            </a:avLst>
-          </a:prstGeom>
-          <a:solidFill>
-            <a:srgbClr val="F0FDFA"/>
-          </a:solidFill>
-          <a:ln w="12700">
-            <a:solidFill>
-              <a:srgbClr val="D8DEE4"/>
-            </a:solidFill>
-          </a:ln>
-          <a:effectLst/>
-        </p:spPr>
-        <p:style>
-          <a:lnRef idx="1">
-            <a:schemeClr val="accent1"/>
-          </a:lnRef>
-          <a:fillRef idx="3">
-            <a:schemeClr val="accent1"/>
-          </a:fillRef>
-          <a:effectRef idx="2">
-            <a:schemeClr val="accent1"/>
-          </a:effectRef>
-          <a:fontRef idx="minor">
-            <a:schemeClr val="lt1"/>
-          </a:fontRef>
-        </p:style>
-        <p:txBody>
-          <a:bodyPr rtlCol="0" anchor="ctr"/>
-          <a:lstStyle/>
-          <a:p>
-            <a:pPr algn="ctr"/>
-          </a:p>
-        </p:txBody>
-      </p:sp>
-      <p:sp>
-        <p:nvSpPr>
-          <p:cNvPr id="15" name="TextBox 14"/>
-          <p:cNvSpPr txBox="1"/>
-          <p:nvPr/>
-        </p:nvSpPr>
-        <p:spPr>
-          <a:xfrm>
-            <a:off x="7550200" y="2084832"/>
-            <a:ext cx="1608429" cy="457200"/>
-          </a:xfrm>
-          <a:prstGeom prst="rect">
-            <a:avLst/>
-          </a:prstGeom>
-          <a:noFill/>
-        </p:spPr>
-        <p:txBody>
-          <a:bodyPr wrap="square" lIns="0" rIns="0" tIns="0" bIns="0" anchor="t">
-            <a:spAutoFit/>
-          </a:bodyPr>
-          <a:lstStyle/>
-          <a:p>
-            <a:pPr algn="l">
-              <a:lnSpc>
-                <a:spcPct val="100000"/>
-              </a:lnSpc>
-              <a:spcBef>
-                <a:spcPts val="0"/>
-              </a:spcBef>
-              <a:spcAft>
-                <a:spcPts val="300"/>
-              </a:spcAft>
-            </a:pPr>
-            <a:r>
-              <a:rPr sz="3000" b="1" i="0">
-                <a:solidFill>
-                  <a:srgbClr val="0F766E"/>
-                </a:solidFill>
-                <a:latin typeface="Arial"/>
-              </a:rPr>
-              <a:t>1 to 2%</a:t>
-            </a:r>
-          </a:p>
-          <a:p>
-            <a:pPr algn="l">
-              <a:lnSpc>
-                <a:spcPct val="115000"/>
-              </a:lnSpc>
-              <a:spcBef>
-                <a:spcPts val="0"/>
-              </a:spcBef>
-              <a:spcAft>
-                <a:spcPts val="300"/>
-              </a:spcAft>
-            </a:pPr>
-            <a:r>
-              <a:rPr sz="1100" b="1" i="0">
-                <a:solidFill>
-                  <a:srgbClr val="1A2733"/>
-                </a:solidFill>
-                <a:latin typeface="Arial"/>
-              </a:rPr>
-              <a:t>consumer conversion</a:t>
-            </a:r>
-          </a:p>
-        </p:txBody>
-      </p:sp>
-      <p:sp>
-        <p:nvSpPr>
-          <p:cNvPr id="16" name="Rounded Rectangle 15"/>
-          <p:cNvSpPr/>
-          <p:nvPr/>
-        </p:nvSpPr>
-        <p:spPr>
-          <a:xfrm>
-            <a:off x="566928" y="2871216"/>
-            <a:ext cx="2613583" cy="1572768"/>
+            <a:ext cx="2613583" cy="2066543"/>
           </a:xfrm>
           <a:prstGeom prst="roundRect">
             <a:avLst>
@@ -31268,14 +30808,58 @@
       </p:sp>
       <p:sp>
         <p:nvSpPr>
-          <p:cNvPr id="17" name="Rectangle 16"/>
+          <p:cNvPr id="9" name="Rectangle 8"/>
           <p:cNvSpPr/>
           <p:nvPr/>
         </p:nvSpPr>
         <p:spPr>
           <a:xfrm>
-            <a:off x="566928" y="3035808"/>
-            <a:ext cx="41148" cy="1243584"/>
+            <a:off x="566928" y="1883664"/>
+            <a:ext cx="2613583" cy="804672"/>
+          </a:xfrm>
+          <a:prstGeom prst="rect">
+            <a:avLst/>
+          </a:prstGeom>
+          <a:solidFill>
+            <a:srgbClr val="F1F5F4"/>
+          </a:solidFill>
+          <a:ln>
+            <a:noFill/>
+          </a:ln>
+          <a:effectLst/>
+        </p:spPr>
+        <p:style>
+          <a:lnRef idx="1">
+            <a:schemeClr val="accent1"/>
+          </a:lnRef>
+          <a:fillRef idx="3">
+            <a:schemeClr val="accent1"/>
+          </a:fillRef>
+          <a:effectRef idx="2">
+            <a:schemeClr val="accent1"/>
+          </a:effectRef>
+          <a:fontRef idx="minor">
+            <a:schemeClr val="lt1"/>
+          </a:fontRef>
+        </p:style>
+        <p:txBody>
+          <a:bodyPr rtlCol="0" anchor="ctr"/>
+          <a:lstStyle/>
+          <a:p>
+            <a:pPr algn="ctr"/>
+          </a:p>
+        </p:txBody>
+      </p:sp>
+      <p:sp>
+        <p:nvSpPr>
+          <p:cNvPr id="10" name="Rectangle 9"/>
+          <p:cNvSpPr/>
+          <p:nvPr/>
+        </p:nvSpPr>
+        <p:spPr>
+          <a:xfrm>
+            <a:off x="566928" y="1883664"/>
+            <a:ext cx="45720" cy="2066543"/>
           </a:xfrm>
           <a:prstGeom prst="rect">
             <a:avLst/>
@@ -31312,14 +30896,14 @@
       </p:sp>
       <p:sp>
         <p:nvSpPr>
-          <p:cNvPr id="18" name="TextBox 17"/>
-          <p:cNvSpPr txBox="1"/>
-          <p:nvPr/>
-        </p:nvSpPr>
-        <p:spPr>
-          <a:xfrm>
-            <a:off x="822960" y="3054096"/>
-            <a:ext cx="2156383" cy="1243584"/>
+          <p:cNvPr id="11" name="TextBox 10"/>
+          <p:cNvSpPr txBox="1"/>
+          <p:nvPr/>
+        </p:nvSpPr>
+        <p:spPr>
+          <a:xfrm>
+            <a:off x="749808" y="2002536"/>
+            <a:ext cx="2284399" cy="219456"/>
           </a:xfrm>
           <a:prstGeom prst="rect">
             <a:avLst/>
@@ -31333,35 +30917,97 @@
           <a:lstStyle/>
           <a:p>
             <a:pPr algn="l">
+              <a:spcBef>
+                <a:spcPts val="0"/>
+              </a:spcBef>
+              <a:spcAft>
+                <a:spcPts val="0"/>
+              </a:spcAft>
+            </a:pPr>
+            <a:r>
+              <a:rPr sz="900" b="1" i="0">
+                <a:solidFill>
+                  <a:srgbClr val="0F766E"/>
+                </a:solidFill>
+                <a:latin typeface="Arial"/>
+              </a:rPr>
+              <a:t>DAGAR FREE</a:t>
+            </a:r>
+          </a:p>
+        </p:txBody>
+      </p:sp>
+      <p:sp>
+        <p:nvSpPr>
+          <p:cNvPr id="12" name="TextBox 11"/>
+          <p:cNvSpPr txBox="1"/>
+          <p:nvPr/>
+        </p:nvSpPr>
+        <p:spPr>
+          <a:xfrm>
+            <a:off x="749808" y="2231136"/>
+            <a:ext cx="2284399" cy="402336"/>
+          </a:xfrm>
+          <a:prstGeom prst="rect">
+            <a:avLst/>
+          </a:prstGeom>
+          <a:noFill/>
+        </p:spPr>
+        <p:txBody>
+          <a:bodyPr wrap="square" lIns="0" rIns="0" tIns="0" bIns="0" anchor="t">
+            <a:spAutoFit/>
+          </a:bodyPr>
+          <a:lstStyle/>
+          <a:p>
+            <a:pPr algn="l">
+              <a:spcBef>
+                <a:spcPts val="0"/>
+              </a:spcBef>
+              <a:spcAft>
+                <a:spcPts val="0"/>
+              </a:spcAft>
+            </a:pPr>
+            <a:r>
+              <a:rPr sz="1700" b="1" i="0">
+                <a:solidFill>
+                  <a:srgbClr val="1A2733"/>
+                </a:solidFill>
+                <a:latin typeface="Arial"/>
+              </a:rPr>
+              <a:t>₹0</a:t>
+            </a:r>
+          </a:p>
+        </p:txBody>
+      </p:sp>
+      <p:sp>
+        <p:nvSpPr>
+          <p:cNvPr id="13" name="TextBox 12"/>
+          <p:cNvSpPr txBox="1"/>
+          <p:nvPr/>
+        </p:nvSpPr>
+        <p:spPr>
+          <a:xfrm>
+            <a:off x="749808" y="2816352"/>
+            <a:ext cx="2284399" cy="1042415"/>
+          </a:xfrm>
+          <a:prstGeom prst="rect">
+            <a:avLst/>
+          </a:prstGeom>
+          <a:noFill/>
+        </p:spPr>
+        <p:txBody>
+          <a:bodyPr wrap="square" lIns="0" rIns="0" tIns="0" bIns="0" anchor="t">
+            <a:spAutoFit/>
+          </a:bodyPr>
+          <a:lstStyle/>
+          <a:p>
+            <a:pPr algn="l">
               <a:lnSpc>
-                <a:spcPct val="105000"/>
+                <a:spcPct val="128000"/>
               </a:lnSpc>
               <a:spcBef>
                 <a:spcPts val="0"/>
               </a:spcBef>
               <a:spcAft>
-                <a:spcPts val="500"/>
-              </a:spcAft>
-            </a:pPr>
-            <a:r>
-              <a:rPr sz="1150" b="1" i="0">
-                <a:solidFill>
-                  <a:srgbClr val="1A2733"/>
-                </a:solidFill>
-                <a:latin typeface="Arial"/>
-              </a:rPr>
-              <a:t>Four tiers, one rule</a:t>
-            </a:r>
-          </a:p>
-          <a:p>
-            <a:pPr algn="l">
-              <a:lnSpc>
-                <a:spcPct val="122000"/>
-              </a:lnSpc>
-              <a:spcBef>
-                <a:spcPts val="0"/>
-              </a:spcBef>
-              <a:spcAft>
                 <a:spcPts val="0"/>
               </a:spcAft>
             </a:pPr>
@@ -31372,21 +31018,21 @@
                 </a:solidFill>
                 <a:latin typeface="Arial"/>
               </a:rPr>
-              <a:t>Free keeps the whole loop: curriculum, practice, quizzes, progress, parent summary, tutor capped at 10 questions a day. Plus is ₹99 a month for unlimited tutoring and depth. Mentor adds ₹299 and only sells once mentors exist. Institutions pay ₹450 to ₹600 a learner.</a:t>
-            </a:r>
-          </a:p>
-        </p:txBody>
-      </p:sp>
-      <p:sp>
-        <p:nvSpPr>
-          <p:cNvPr id="19" name="Rounded Rectangle 18"/>
+              <a:t>Everything needed to learn. Full curriculum, lessons, practice, quizzes, progress, streaks and the parent summary. AI tutor capped at 10 questions a day.</a:t>
+            </a:r>
+          </a:p>
+        </p:txBody>
+      </p:sp>
+      <p:sp>
+        <p:nvSpPr>
+          <p:cNvPr id="14" name="Rounded Rectangle 13"/>
           <p:cNvSpPr/>
           <p:nvPr/>
         </p:nvSpPr>
         <p:spPr>
           <a:xfrm>
-            <a:off x="3381679" y="2871216"/>
-            <a:ext cx="2613583" cy="1572768"/>
+            <a:off x="3381679" y="1883664"/>
+            <a:ext cx="2613583" cy="2066543"/>
           </a:xfrm>
           <a:prstGeom prst="roundRect">
             <a:avLst>
@@ -31427,20 +31073,20 @@
       </p:sp>
       <p:sp>
         <p:nvSpPr>
-          <p:cNvPr id="20" name="Rectangle 19"/>
+          <p:cNvPr id="15" name="Rectangle 14"/>
           <p:cNvSpPr/>
           <p:nvPr/>
         </p:nvSpPr>
         <p:spPr>
           <a:xfrm>
-            <a:off x="3381679" y="3035808"/>
-            <a:ext cx="41148" cy="1243584"/>
+            <a:off x="3381679" y="1883664"/>
+            <a:ext cx="2613583" cy="804672"/>
           </a:xfrm>
           <a:prstGeom prst="rect">
             <a:avLst/>
           </a:prstGeom>
           <a:solidFill>
-            <a:srgbClr val="B45309"/>
+            <a:srgbClr val="F1F5F4"/>
           </a:solidFill>
           <a:ln>
             <a:noFill/>
@@ -31471,14 +31117,58 @@
       </p:sp>
       <p:sp>
         <p:nvSpPr>
-          <p:cNvPr id="21" name="TextBox 20"/>
-          <p:cNvSpPr txBox="1"/>
-          <p:nvPr/>
-        </p:nvSpPr>
-        <p:spPr>
-          <a:xfrm>
-            <a:off x="3637711" y="3054096"/>
-            <a:ext cx="2156383" cy="1243584"/>
+          <p:cNvPr id="16" name="Rectangle 15"/>
+          <p:cNvSpPr/>
+          <p:nvPr/>
+        </p:nvSpPr>
+        <p:spPr>
+          <a:xfrm>
+            <a:off x="3381679" y="1883664"/>
+            <a:ext cx="45720" cy="2066543"/>
+          </a:xfrm>
+          <a:prstGeom prst="rect">
+            <a:avLst/>
+          </a:prstGeom>
+          <a:solidFill>
+            <a:srgbClr val="0F766E"/>
+          </a:solidFill>
+          <a:ln>
+            <a:noFill/>
+          </a:ln>
+          <a:effectLst/>
+        </p:spPr>
+        <p:style>
+          <a:lnRef idx="1">
+            <a:schemeClr val="accent1"/>
+          </a:lnRef>
+          <a:fillRef idx="3">
+            <a:schemeClr val="accent1"/>
+          </a:fillRef>
+          <a:effectRef idx="2">
+            <a:schemeClr val="accent1"/>
+          </a:effectRef>
+          <a:fontRef idx="minor">
+            <a:schemeClr val="lt1"/>
+          </a:fontRef>
+        </p:style>
+        <p:txBody>
+          <a:bodyPr rtlCol="0" anchor="ctr"/>
+          <a:lstStyle/>
+          <a:p>
+            <a:pPr algn="ctr"/>
+          </a:p>
+        </p:txBody>
+      </p:sp>
+      <p:sp>
+        <p:nvSpPr>
+          <p:cNvPr id="17" name="TextBox 16"/>
+          <p:cNvSpPr txBox="1"/>
+          <p:nvPr/>
+        </p:nvSpPr>
+        <p:spPr>
+          <a:xfrm>
+            <a:off x="3564559" y="2002536"/>
+            <a:ext cx="2284399" cy="219456"/>
           </a:xfrm>
           <a:prstGeom prst="rect">
             <a:avLst/>
@@ -31492,35 +31182,97 @@
           <a:lstStyle/>
           <a:p>
             <a:pPr algn="l">
+              <a:spcBef>
+                <a:spcPts val="0"/>
+              </a:spcBef>
+              <a:spcAft>
+                <a:spcPts val="0"/>
+              </a:spcAft>
+            </a:pPr>
+            <a:r>
+              <a:rPr sz="900" b="1" i="0">
+                <a:solidFill>
+                  <a:srgbClr val="0F766E"/>
+                </a:solidFill>
+                <a:latin typeface="Arial"/>
+              </a:rPr>
+              <a:t>DAGAR PLUS</a:t>
+            </a:r>
+          </a:p>
+        </p:txBody>
+      </p:sp>
+      <p:sp>
+        <p:nvSpPr>
+          <p:cNvPr id="18" name="TextBox 17"/>
+          <p:cNvSpPr txBox="1"/>
+          <p:nvPr/>
+        </p:nvSpPr>
+        <p:spPr>
+          <a:xfrm>
+            <a:off x="3564559" y="2231136"/>
+            <a:ext cx="2284399" cy="402336"/>
+          </a:xfrm>
+          <a:prstGeom prst="rect">
+            <a:avLst/>
+          </a:prstGeom>
+          <a:noFill/>
+        </p:spPr>
+        <p:txBody>
+          <a:bodyPr wrap="square" lIns="0" rIns="0" tIns="0" bIns="0" anchor="t">
+            <a:spAutoFit/>
+          </a:bodyPr>
+          <a:lstStyle/>
+          <a:p>
+            <a:pPr algn="l">
+              <a:spcBef>
+                <a:spcPts val="0"/>
+              </a:spcBef>
+              <a:spcAft>
+                <a:spcPts val="0"/>
+              </a:spcAft>
+            </a:pPr>
+            <a:r>
+              <a:rPr sz="1700" b="1" i="0">
+                <a:solidFill>
+                  <a:srgbClr val="1A2733"/>
+                </a:solidFill>
+                <a:latin typeface="Arial"/>
+              </a:rPr>
+              <a:t>₹99 / month</a:t>
+            </a:r>
+          </a:p>
+        </p:txBody>
+      </p:sp>
+      <p:sp>
+        <p:nvSpPr>
+          <p:cNvPr id="19" name="TextBox 18"/>
+          <p:cNvSpPr txBox="1"/>
+          <p:nvPr/>
+        </p:nvSpPr>
+        <p:spPr>
+          <a:xfrm>
+            <a:off x="3564559" y="2816352"/>
+            <a:ext cx="2284399" cy="1042415"/>
+          </a:xfrm>
+          <a:prstGeom prst="rect">
+            <a:avLst/>
+          </a:prstGeom>
+          <a:noFill/>
+        </p:spPr>
+        <p:txBody>
+          <a:bodyPr wrap="square" lIns="0" rIns="0" tIns="0" bIns="0" anchor="t">
+            <a:spAutoFit/>
+          </a:bodyPr>
+          <a:lstStyle/>
+          <a:p>
+            <a:pPr algn="l">
               <a:lnSpc>
-                <a:spcPct val="105000"/>
+                <a:spcPct val="128000"/>
               </a:lnSpc>
               <a:spcBef>
                 <a:spcPts val="0"/>
               </a:spcBef>
               <a:spcAft>
-                <a:spcPts val="500"/>
-              </a:spcAft>
-            </a:pPr>
-            <a:r>
-              <a:rPr sz="1150" b="1" i="0">
-                <a:solidFill>
-                  <a:srgbClr val="1A2733"/>
-                </a:solidFill>
-                <a:latin typeface="Arial"/>
-              </a:rPr>
-              <a:t>The floor is a cost, not a target</a:t>
-            </a:r>
-          </a:p>
-          <a:p>
-            <a:pPr algn="l">
-              <a:lnSpc>
-                <a:spcPct val="122000"/>
-              </a:lnSpc>
-              <a:spcBef>
-                <a:spcPts val="0"/>
-              </a:spcBef>
-              <a:spcAft>
                 <a:spcPts val="0"/>
               </a:spcAft>
             </a:pPr>
@@ -31531,21 +31283,21 @@
                 </a:solidFill>
                 <a:latin typeface="Arial"/>
               </a:rPr>
-              <a:t>A fully active learner costs about ₹370 a year, roughly ₹330 of AI and ₹40 of infrastructure. No institutional licence is priced below it. This is modelled from published token pricing, not measured per learner, and we say which it is.</a:t>
-            </a:r>
-          </a:p>
-        </p:txBody>
-      </p:sp>
-      <p:sp>
-        <p:nvSpPr>
-          <p:cNvPr id="22" name="Rounded Rectangle 21"/>
+              <a:t>Depth, for the families who want it and can pay. Unlimited AI tutor, deeper adaptive practice, revision plans and fuller parent insight.</a:t>
+            </a:r>
+          </a:p>
+        </p:txBody>
+      </p:sp>
+      <p:sp>
+        <p:nvSpPr>
+          <p:cNvPr id="20" name="Rounded Rectangle 19"/>
           <p:cNvSpPr/>
           <p:nvPr/>
         </p:nvSpPr>
         <p:spPr>
           <a:xfrm>
-            <a:off x="6196431" y="2871216"/>
-            <a:ext cx="2613583" cy="1572768"/>
+            <a:off x="6196431" y="1883664"/>
+            <a:ext cx="2613583" cy="2066543"/>
           </a:xfrm>
           <a:prstGeom prst="roundRect">
             <a:avLst>
@@ -31586,20 +31338,20 @@
       </p:sp>
       <p:sp>
         <p:nvSpPr>
-          <p:cNvPr id="23" name="Rectangle 22"/>
+          <p:cNvPr id="21" name="Rectangle 20"/>
           <p:cNvSpPr/>
           <p:nvPr/>
         </p:nvSpPr>
         <p:spPr>
           <a:xfrm>
-            <a:off x="6196431" y="3035808"/>
-            <a:ext cx="41148" cy="1243584"/>
+            <a:off x="6196431" y="1883664"/>
+            <a:ext cx="2613583" cy="804672"/>
           </a:xfrm>
           <a:prstGeom prst="rect">
             <a:avLst/>
           </a:prstGeom>
           <a:solidFill>
-            <a:srgbClr val="0F766E"/>
+            <a:srgbClr val="F1F5F4"/>
           </a:solidFill>
           <a:ln>
             <a:noFill/>
@@ -31630,14 +31382,100 @@
       </p:sp>
       <p:sp>
         <p:nvSpPr>
+          <p:cNvPr id="22" name="Rectangle 21"/>
+          <p:cNvSpPr/>
+          <p:nvPr/>
+        </p:nvSpPr>
+        <p:spPr>
+          <a:xfrm>
+            <a:off x="6196431" y="1883664"/>
+            <a:ext cx="45720" cy="2066543"/>
+          </a:xfrm>
+          <a:prstGeom prst="rect">
+            <a:avLst/>
+          </a:prstGeom>
+          <a:solidFill>
+            <a:srgbClr val="5B6673"/>
+          </a:solidFill>
+          <a:ln>
+            <a:noFill/>
+          </a:ln>
+          <a:effectLst/>
+        </p:spPr>
+        <p:style>
+          <a:lnRef idx="1">
+            <a:schemeClr val="accent1"/>
+          </a:lnRef>
+          <a:fillRef idx="3">
+            <a:schemeClr val="accent1"/>
+          </a:fillRef>
+          <a:effectRef idx="2">
+            <a:schemeClr val="accent1"/>
+          </a:effectRef>
+          <a:fontRef idx="minor">
+            <a:schemeClr val="lt1"/>
+          </a:fontRef>
+        </p:style>
+        <p:txBody>
+          <a:bodyPr rtlCol="0" anchor="ctr"/>
+          <a:lstStyle/>
+          <a:p>
+            <a:pPr algn="ctr"/>
+          </a:p>
+        </p:txBody>
+      </p:sp>
+      <p:sp>
+        <p:nvSpPr>
+          <p:cNvPr id="23" name="TextBox 22"/>
+          <p:cNvSpPr txBox="1"/>
+          <p:nvPr/>
+        </p:nvSpPr>
+        <p:spPr>
+          <a:xfrm>
+            <a:off x="6379311" y="2002536"/>
+            <a:ext cx="2284399" cy="219456"/>
+          </a:xfrm>
+          <a:prstGeom prst="rect">
+            <a:avLst/>
+          </a:prstGeom>
+          <a:noFill/>
+        </p:spPr>
+        <p:txBody>
+          <a:bodyPr wrap="square" lIns="0" rIns="0" tIns="0" bIns="0" anchor="t">
+            <a:spAutoFit/>
+          </a:bodyPr>
+          <a:lstStyle/>
+          <a:p>
+            <a:pPr algn="l">
+              <a:spcBef>
+                <a:spcPts val="0"/>
+              </a:spcBef>
+              <a:spcAft>
+                <a:spcPts val="0"/>
+              </a:spcAft>
+            </a:pPr>
+            <a:r>
+              <a:rPr sz="900" b="1" i="0">
+                <a:solidFill>
+                  <a:srgbClr val="5B6673"/>
+                </a:solidFill>
+                <a:latin typeface="Arial"/>
+              </a:rPr>
+              <a:t>DAGAR MENTOR</a:t>
+            </a:r>
+          </a:p>
+        </p:txBody>
+      </p:sp>
+      <p:sp>
+        <p:nvSpPr>
           <p:cNvPr id="24" name="TextBox 23"/>
           <p:cNvSpPr txBox="1"/>
           <p:nvPr/>
         </p:nvSpPr>
         <p:spPr>
           <a:xfrm>
-            <a:off x="6452463" y="3054096"/>
-            <a:ext cx="2156383" cy="1243584"/>
+            <a:off x="6379311" y="2231136"/>
+            <a:ext cx="2284399" cy="402336"/>
           </a:xfrm>
           <a:prstGeom prst="rect">
             <a:avLst/>
@@ -31651,35 +31489,55 @@
           <a:lstStyle/>
           <a:p>
             <a:pPr algn="l">
+              <a:spcBef>
+                <a:spcPts val="0"/>
+              </a:spcBef>
+              <a:spcAft>
+                <a:spcPts val="0"/>
+              </a:spcAft>
+            </a:pPr>
+            <a:r>
+              <a:rPr sz="1700" b="1" i="0">
+                <a:solidFill>
+                  <a:srgbClr val="1A2733"/>
+                </a:solidFill>
+                <a:latin typeface="Arial"/>
+              </a:rPr>
+              <a:t>+ ₹299 / month</a:t>
+            </a:r>
+          </a:p>
+        </p:txBody>
+      </p:sp>
+      <p:sp>
+        <p:nvSpPr>
+          <p:cNvPr id="25" name="TextBox 24"/>
+          <p:cNvSpPr txBox="1"/>
+          <p:nvPr/>
+        </p:nvSpPr>
+        <p:spPr>
+          <a:xfrm>
+            <a:off x="6379311" y="2816352"/>
+            <a:ext cx="2284399" cy="1042415"/>
+          </a:xfrm>
+          <a:prstGeom prst="rect">
+            <a:avLst/>
+          </a:prstGeom>
+          <a:noFill/>
+        </p:spPr>
+        <p:txBody>
+          <a:bodyPr wrap="square" lIns="0" rIns="0" tIns="0" bIns="0" anchor="t">
+            <a:spAutoFit/>
+          </a:bodyPr>
+          <a:lstStyle/>
+          <a:p>
+            <a:pPr algn="l">
               <a:lnSpc>
-                <a:spcPct val="105000"/>
+                <a:spcPct val="128000"/>
               </a:lnSpc>
               <a:spcBef>
                 <a:spcPts val="0"/>
               </a:spcBef>
               <a:spcAft>
-                <a:spcPts val="500"/>
-              </a:spcAft>
-            </a:pPr>
-            <a:r>
-              <a:rPr sz="1150" b="1" i="0">
-                <a:solidFill>
-                  <a:srgbClr val="1A2733"/>
-                </a:solidFill>
-                <a:latin typeface="Arial"/>
-              </a:rPr>
-              <a:t>Institutions, because the maths works</a:t>
-            </a:r>
-          </a:p>
-          <a:p>
-            <a:pPr algn="l">
-              <a:lnSpc>
-                <a:spcPct val="122000"/>
-              </a:lnSpc>
-              <a:spcBef>
-                <a:spcPts val="0"/>
-              </a:spcBef>
-              <a:spcAft>
                 <a:spcPts val="0"/>
               </a:spcAft>
             </a:pPr>
@@ -31690,21 +31548,21 @@
                 </a:solidFill>
                 <a:latin typeface="Arial"/>
               </a:rPr>
-              <a:t>Conversion among families who cannot afford tuition is realistically 1 to 2%. CSR budgets are mandated in India and already buy per beneficiary, so one NGO cohort beats a thousand families we would rather not charge.</a:t>
-            </a:r>
-          </a:p>
-        </p:txBody>
-      </p:sp>
-      <p:sp>
-        <p:nvSpPr>
-          <p:cNvPr id="25" name="Rounded Rectangle 24"/>
+              <a:t>Sessions with a real person. Not sold until mentors are verified and on call, because selling ahead of supply loses a parent's trust once and for good.</a:t>
+            </a:r>
+          </a:p>
+        </p:txBody>
+      </p:sp>
+      <p:sp>
+        <p:nvSpPr>
+          <p:cNvPr id="26" name="Rounded Rectangle 25"/>
           <p:cNvSpPr/>
           <p:nvPr/>
         </p:nvSpPr>
         <p:spPr>
           <a:xfrm>
-            <a:off x="9011183" y="2871216"/>
-            <a:ext cx="2613583" cy="1572768"/>
+            <a:off x="9011183" y="1883664"/>
+            <a:ext cx="2613583" cy="2066543"/>
           </a:xfrm>
           <a:prstGeom prst="roundRect">
             <a:avLst>
@@ -31745,14 +31603,58 @@
       </p:sp>
       <p:sp>
         <p:nvSpPr>
-          <p:cNvPr id="26" name="Rectangle 25"/>
+          <p:cNvPr id="27" name="Rectangle 26"/>
           <p:cNvSpPr/>
           <p:nvPr/>
         </p:nvSpPr>
         <p:spPr>
           <a:xfrm>
-            <a:off x="9011183" y="3035808"/>
-            <a:ext cx="41148" cy="1243584"/>
+            <a:off x="9011183" y="1883664"/>
+            <a:ext cx="2613583" cy="804672"/>
+          </a:xfrm>
+          <a:prstGeom prst="rect">
+            <a:avLst/>
+          </a:prstGeom>
+          <a:solidFill>
+            <a:srgbClr val="F1F5F4"/>
+          </a:solidFill>
+          <a:ln>
+            <a:noFill/>
+          </a:ln>
+          <a:effectLst/>
+        </p:spPr>
+        <p:style>
+          <a:lnRef idx="1">
+            <a:schemeClr val="accent1"/>
+          </a:lnRef>
+          <a:fillRef idx="3">
+            <a:schemeClr val="accent1"/>
+          </a:fillRef>
+          <a:effectRef idx="2">
+            <a:schemeClr val="accent1"/>
+          </a:effectRef>
+          <a:fontRef idx="minor">
+            <a:schemeClr val="lt1"/>
+          </a:fontRef>
+        </p:style>
+        <p:txBody>
+          <a:bodyPr rtlCol="0" anchor="ctr"/>
+          <a:lstStyle/>
+          <a:p>
+            <a:pPr algn="ctr"/>
+          </a:p>
+        </p:txBody>
+      </p:sp>
+      <p:sp>
+        <p:nvSpPr>
+          <p:cNvPr id="28" name="Rectangle 27"/>
+          <p:cNvSpPr/>
+          <p:nvPr/>
+        </p:nvSpPr>
+        <p:spPr>
+          <a:xfrm>
+            <a:off x="9011183" y="1883664"/>
+            <a:ext cx="45720" cy="2066543"/>
           </a:xfrm>
           <a:prstGeom prst="rect">
             <a:avLst/>
@@ -31789,14 +31691,14 @@
       </p:sp>
       <p:sp>
         <p:nvSpPr>
-          <p:cNvPr id="27" name="TextBox 26"/>
-          <p:cNvSpPr txBox="1"/>
-          <p:nvPr/>
-        </p:nvSpPr>
-        <p:spPr>
-          <a:xfrm>
-            <a:off x="9267215" y="3054096"/>
-            <a:ext cx="2156383" cy="1243584"/>
+          <p:cNvPr id="29" name="TextBox 28"/>
+          <p:cNvSpPr txBox="1"/>
+          <p:nvPr/>
+        </p:nvSpPr>
+        <p:spPr>
+          <a:xfrm>
+            <a:off x="9194063" y="2002536"/>
+            <a:ext cx="2284399" cy="219456"/>
           </a:xfrm>
           <a:prstGeom prst="rect">
             <a:avLst/>
@@ -31810,35 +31712,97 @@
           <a:lstStyle/>
           <a:p>
             <a:pPr algn="l">
+              <a:spcBef>
+                <a:spcPts val="0"/>
+              </a:spcBef>
+              <a:spcAft>
+                <a:spcPts val="0"/>
+              </a:spcAft>
+            </a:pPr>
+            <a:r>
+              <a:rPr sz="900" b="1" i="0">
+                <a:solidFill>
+                  <a:srgbClr val="B45309"/>
+                </a:solidFill>
+                <a:latin typeface="Arial"/>
+              </a:rPr>
+              <a:t>INSTITUTIONS</a:t>
+            </a:r>
+          </a:p>
+        </p:txBody>
+      </p:sp>
+      <p:sp>
+        <p:nvSpPr>
+          <p:cNvPr id="30" name="TextBox 29"/>
+          <p:cNvSpPr txBox="1"/>
+          <p:nvPr/>
+        </p:nvSpPr>
+        <p:spPr>
+          <a:xfrm>
+            <a:off x="9194063" y="2231136"/>
+            <a:ext cx="2284399" cy="402336"/>
+          </a:xfrm>
+          <a:prstGeom prst="rect">
+            <a:avLst/>
+          </a:prstGeom>
+          <a:noFill/>
+        </p:spPr>
+        <p:txBody>
+          <a:bodyPr wrap="square" lIns="0" rIns="0" tIns="0" bIns="0" anchor="t">
+            <a:spAutoFit/>
+          </a:bodyPr>
+          <a:lstStyle/>
+          <a:p>
+            <a:pPr algn="l">
+              <a:spcBef>
+                <a:spcPts val="0"/>
+              </a:spcBef>
+              <a:spcAft>
+                <a:spcPts val="0"/>
+              </a:spcAft>
+            </a:pPr>
+            <a:r>
+              <a:rPr sz="1700" b="1" i="0">
+                <a:solidFill>
+                  <a:srgbClr val="1A2733"/>
+                </a:solidFill>
+                <a:latin typeface="Arial"/>
+              </a:rPr>
+              <a:t>₹450 to ₹600</a:t>
+            </a:r>
+          </a:p>
+        </p:txBody>
+      </p:sp>
+      <p:sp>
+        <p:nvSpPr>
+          <p:cNvPr id="31" name="TextBox 30"/>
+          <p:cNvSpPr txBox="1"/>
+          <p:nvPr/>
+        </p:nvSpPr>
+        <p:spPr>
+          <a:xfrm>
+            <a:off x="9194063" y="2816352"/>
+            <a:ext cx="2284399" cy="1042415"/>
+          </a:xfrm>
+          <a:prstGeom prst="rect">
+            <a:avLst/>
+          </a:prstGeom>
+          <a:noFill/>
+        </p:spPr>
+        <p:txBody>
+          <a:bodyPr wrap="square" lIns="0" rIns="0" tIns="0" bIns="0" anchor="t">
+            <a:spAutoFit/>
+          </a:bodyPr>
+          <a:lstStyle/>
+          <a:p>
+            <a:pPr algn="l">
               <a:lnSpc>
-                <a:spcPct val="105000"/>
+                <a:spcPct val="128000"/>
               </a:lnSpc>
               <a:spcBef>
                 <a:spcPts val="0"/>
               </a:spcBef>
               <a:spcAft>
-                <a:spcPts val="500"/>
-              </a:spcAft>
-            </a:pPr>
-            <a:r>
-              <a:rPr sz="1150" b="1" i="0">
-                <a:solidFill>
-                  <a:srgbClr val="1A2733"/>
-                </a:solidFill>
-                <a:latin typeface="Arial"/>
-              </a:rPr>
-              <a:t>Advertising is not on the table</a:t>
-            </a:r>
-          </a:p>
-          <a:p>
-            <a:pPr algn="l">
-              <a:lnSpc>
-                <a:spcPct val="122000"/>
-              </a:lnSpc>
-              <a:spcBef>
-                <a:spcPts val="0"/>
-              </a:spcBef>
-              <a:spcAft>
                 <a:spcPts val="0"/>
               </a:spcAft>
             </a:pPr>
@@ -31849,21 +31813,21 @@
                 </a:solidFill>
                 <a:latin typeface="Arial"/>
               </a:rPr>
-              <a:t>The DPDP Act 2023 forbids behavioural tracking and targeted advertising directed at anyone under 18, and parental consent does not unlock it. Our entire user base is 11 to 14. That closes the default way free products make money, and we would not want it open.</a:t>
-            </a:r>
-          </a:p>
-        </p:txBody>
-      </p:sp>
-      <p:sp>
-        <p:nvSpPr>
-          <p:cNvPr id="28" name="Rounded Rectangle 27"/>
+              <a:t>Per learner, per year. The scalable engine: NGO, CSR and government licences with cohort dashboards, reporting and bulk onboarding.</a:t>
+            </a:r>
+          </a:p>
+        </p:txBody>
+      </p:sp>
+      <p:sp>
+        <p:nvSpPr>
+          <p:cNvPr id="32" name="Rounded Rectangle 31"/>
           <p:cNvSpPr/>
           <p:nvPr/>
         </p:nvSpPr>
         <p:spPr>
           <a:xfrm>
-            <a:off x="566928" y="4626864"/>
-            <a:ext cx="11057839" cy="1042415"/>
+            <a:off x="566928" y="4151376"/>
+            <a:ext cx="3551834" cy="1481328"/>
           </a:xfrm>
           <a:prstGeom prst="roundRect">
             <a:avLst>
@@ -31871,7 +31835,7 @@
             </a:avLst>
           </a:prstGeom>
           <a:solidFill>
-            <a:srgbClr val="F1F5F4"/>
+            <a:srgbClr val="FFFFFF"/>
           </a:solidFill>
           <a:ln w="12700">
             <a:solidFill>
@@ -31904,14 +31868,14 @@
       </p:sp>
       <p:sp>
         <p:nvSpPr>
-          <p:cNvPr id="29" name="Rectangle 28"/>
+          <p:cNvPr id="33" name="Rectangle 32"/>
           <p:cNvSpPr/>
           <p:nvPr/>
         </p:nvSpPr>
         <p:spPr>
           <a:xfrm>
-            <a:off x="566928" y="4809744"/>
-            <a:ext cx="54864" cy="676656"/>
+            <a:off x="566928" y="4315968"/>
+            <a:ext cx="41148" cy="1152144"/>
           </a:xfrm>
           <a:prstGeom prst="rect">
             <a:avLst/>
@@ -31948,14 +31912,14 @@
       </p:sp>
       <p:sp>
         <p:nvSpPr>
-          <p:cNvPr id="30" name="TextBox 29"/>
-          <p:cNvSpPr txBox="1"/>
-          <p:nvPr/>
-        </p:nvSpPr>
-        <p:spPr>
-          <a:xfrm>
-            <a:off x="877824" y="4773168"/>
-            <a:ext cx="10417759" cy="804672"/>
+          <p:cNvPr id="34" name="TextBox 33"/>
+          <p:cNvSpPr txBox="1"/>
+          <p:nvPr/>
+        </p:nvSpPr>
+        <p:spPr>
+          <a:xfrm>
+            <a:off x="822960" y="4334256"/>
+            <a:ext cx="3094634" cy="1152144"/>
           </a:xfrm>
           <a:prstGeom prst="rect">
             <a:avLst/>
@@ -31969,27 +31933,30 @@
           <a:lstStyle/>
           <a:p>
             <a:pPr algn="l">
-              <a:spcBef>
-                <a:spcPts val="0"/>
-              </a:spcBef>
-              <a:spcAft>
-                <a:spcPts val="400"/>
-              </a:spcAft>
-            </a:pPr>
-            <a:r>
-              <a:rPr sz="1250" b="1" i="0">
+              <a:lnSpc>
+                <a:spcPct val="105000"/>
+              </a:lnSpc>
+              <a:spcBef>
+                <a:spcPts val="0"/>
+              </a:spcBef>
+              <a:spcAft>
+                <a:spcPts val="500"/>
+              </a:spcAft>
+            </a:pPr>
+            <a:r>
+              <a:rPr sz="1150" b="1" i="0">
                 <a:solidFill>
                   <a:srgbClr val="1A2733"/>
                 </a:solidFill>
                 <a:latin typeface="Arial"/>
               </a:rPr>
-              <a:t>The margin is thin, and that is the honest headline.</a:t>
+              <a:t>The floor: ₹370 a learner a year</a:t>
             </a:r>
           </a:p>
           <a:p>
             <a:pPr algn="l">
               <a:lnSpc>
-                <a:spcPct val="126000"/>
+                <a:spcPct val="122000"/>
               </a:lnSpc>
               <a:spcBef>
                 <a:spcPts val="0"/>
@@ -31999,13 +31966,331 @@
               </a:spcAft>
             </a:pPr>
             <a:r>
-              <a:rPr sz="1050" b="0" i="0">
+              <a:rPr sz="950" b="0" i="0">
                 <a:solidFill>
                   <a:srgbClr val="3F4A57"/>
                 </a:solidFill>
                 <a:latin typeface="Arial"/>
               </a:rPr>
-              <a:t>₹450 against a ₹370 floor is ₹80 a learner, and the risk is that institutions treat ₹450 as a ceiling rather than a starting point, at which point the margin goes negative. Two things move it: inference prices have fallen every year of this technology's existence, and most learners are not fully active, so a cohort costs less than its worst case. Neither is a plan. The plan is to price above cost, publish the number we are pricing against, and not sell reach we cannot afford to serve.</a:t>
+              <a:t>Roughly ₹330 of AI and ₹40 of infrastructure, modelled from published token pricing rather than measured per learner. Nothing is priced below it, so ₹450 leaves ₹80. Thin, and the risk is an institution treating ₹450 as a ceiling.</a:t>
+            </a:r>
+          </a:p>
+        </p:txBody>
+      </p:sp>
+      <p:sp>
+        <p:nvSpPr>
+          <p:cNvPr id="35" name="Rounded Rectangle 34"/>
+          <p:cNvSpPr/>
+          <p:nvPr/>
+        </p:nvSpPr>
+        <p:spPr>
+          <a:xfrm>
+            <a:off x="4319930" y="4151376"/>
+            <a:ext cx="3551834" cy="1481328"/>
+          </a:xfrm>
+          <a:prstGeom prst="roundRect">
+            <a:avLst>
+              <a:gd name="adj" fmla="val 6000"/>
+            </a:avLst>
+          </a:prstGeom>
+          <a:solidFill>
+            <a:srgbClr val="FFFFFF"/>
+          </a:solidFill>
+          <a:ln w="12700">
+            <a:solidFill>
+              <a:srgbClr val="D8DEE4"/>
+            </a:solidFill>
+          </a:ln>
+          <a:effectLst/>
+        </p:spPr>
+        <p:style>
+          <a:lnRef idx="1">
+            <a:schemeClr val="accent1"/>
+          </a:lnRef>
+          <a:fillRef idx="3">
+            <a:schemeClr val="accent1"/>
+          </a:fillRef>
+          <a:effectRef idx="2">
+            <a:schemeClr val="accent1"/>
+          </a:effectRef>
+          <a:fontRef idx="minor">
+            <a:schemeClr val="lt1"/>
+          </a:fontRef>
+        </p:style>
+        <p:txBody>
+          <a:bodyPr rtlCol="0" anchor="ctr"/>
+          <a:lstStyle/>
+          <a:p>
+            <a:pPr algn="ctr"/>
+          </a:p>
+        </p:txBody>
+      </p:sp>
+      <p:sp>
+        <p:nvSpPr>
+          <p:cNvPr id="36" name="Rectangle 35"/>
+          <p:cNvSpPr/>
+          <p:nvPr/>
+        </p:nvSpPr>
+        <p:spPr>
+          <a:xfrm>
+            <a:off x="4319930" y="4315968"/>
+            <a:ext cx="41148" cy="1152144"/>
+          </a:xfrm>
+          <a:prstGeom prst="rect">
+            <a:avLst/>
+          </a:prstGeom>
+          <a:solidFill>
+            <a:srgbClr val="0F766E"/>
+          </a:solidFill>
+          <a:ln>
+            <a:noFill/>
+          </a:ln>
+          <a:effectLst/>
+        </p:spPr>
+        <p:style>
+          <a:lnRef idx="1">
+            <a:schemeClr val="accent1"/>
+          </a:lnRef>
+          <a:fillRef idx="3">
+            <a:schemeClr val="accent1"/>
+          </a:fillRef>
+          <a:effectRef idx="2">
+            <a:schemeClr val="accent1"/>
+          </a:effectRef>
+          <a:fontRef idx="minor">
+            <a:schemeClr val="lt1"/>
+          </a:fontRef>
+        </p:style>
+        <p:txBody>
+          <a:bodyPr rtlCol="0" anchor="ctr"/>
+          <a:lstStyle/>
+          <a:p>
+            <a:pPr algn="ctr"/>
+          </a:p>
+        </p:txBody>
+      </p:sp>
+      <p:sp>
+        <p:nvSpPr>
+          <p:cNvPr id="37" name="TextBox 36"/>
+          <p:cNvSpPr txBox="1"/>
+          <p:nvPr/>
+        </p:nvSpPr>
+        <p:spPr>
+          <a:xfrm>
+            <a:off x="4575962" y="4334256"/>
+            <a:ext cx="3094634" cy="1152144"/>
+          </a:xfrm>
+          <a:prstGeom prst="rect">
+            <a:avLst/>
+          </a:prstGeom>
+          <a:noFill/>
+        </p:spPr>
+        <p:txBody>
+          <a:bodyPr wrap="square" lIns="0" rIns="0" tIns="0" bIns="0" anchor="t">
+            <a:spAutoFit/>
+          </a:bodyPr>
+          <a:lstStyle/>
+          <a:p>
+            <a:pPr algn="l">
+              <a:lnSpc>
+                <a:spcPct val="105000"/>
+              </a:lnSpc>
+              <a:spcBef>
+                <a:spcPts val="0"/>
+              </a:spcBef>
+              <a:spcAft>
+                <a:spcPts val="500"/>
+              </a:spcAft>
+            </a:pPr>
+            <a:r>
+              <a:rPr sz="1150" b="1" i="0">
+                <a:solidFill>
+                  <a:srgbClr val="1A2733"/>
+                </a:solidFill>
+                <a:latin typeface="Arial"/>
+              </a:rPr>
+              <a:t>Institutions, not families</a:t>
+            </a:r>
+          </a:p>
+          <a:p>
+            <a:pPr algn="l">
+              <a:lnSpc>
+                <a:spcPct val="122000"/>
+              </a:lnSpc>
+              <a:spcBef>
+                <a:spcPts val="0"/>
+              </a:spcBef>
+              <a:spcAft>
+                <a:spcPts val="0"/>
+              </a:spcAft>
+            </a:pPr>
+            <a:r>
+              <a:rPr sz="950" b="0" i="0">
+                <a:solidFill>
+                  <a:srgbClr val="3F4A57"/>
+                </a:solidFill>
+                <a:latin typeface="Arial"/>
+              </a:rPr>
+              <a:t>Conversion among families who cannot afford tuition is realistically 1 to 2%. CSR budgets are mandated in India and already buy per beneficiary, so one NGO cohort beats a thousand families we would rather not charge.</a:t>
+            </a:r>
+          </a:p>
+        </p:txBody>
+      </p:sp>
+      <p:sp>
+        <p:nvSpPr>
+          <p:cNvPr id="38" name="Rounded Rectangle 37"/>
+          <p:cNvSpPr/>
+          <p:nvPr/>
+        </p:nvSpPr>
+        <p:spPr>
+          <a:xfrm>
+            <a:off x="8072932" y="4151376"/>
+            <a:ext cx="3551834" cy="1481328"/>
+          </a:xfrm>
+          <a:prstGeom prst="roundRect">
+            <a:avLst>
+              <a:gd name="adj" fmla="val 6000"/>
+            </a:avLst>
+          </a:prstGeom>
+          <a:solidFill>
+            <a:srgbClr val="FFFFFF"/>
+          </a:solidFill>
+          <a:ln w="12700">
+            <a:solidFill>
+              <a:srgbClr val="D8DEE4"/>
+            </a:solidFill>
+          </a:ln>
+          <a:effectLst/>
+        </p:spPr>
+        <p:style>
+          <a:lnRef idx="1">
+            <a:schemeClr val="accent1"/>
+          </a:lnRef>
+          <a:fillRef idx="3">
+            <a:schemeClr val="accent1"/>
+          </a:fillRef>
+          <a:effectRef idx="2">
+            <a:schemeClr val="accent1"/>
+          </a:effectRef>
+          <a:fontRef idx="minor">
+            <a:schemeClr val="lt1"/>
+          </a:fontRef>
+        </p:style>
+        <p:txBody>
+          <a:bodyPr rtlCol="0" anchor="ctr"/>
+          <a:lstStyle/>
+          <a:p>
+            <a:pPr algn="ctr"/>
+          </a:p>
+        </p:txBody>
+      </p:sp>
+      <p:sp>
+        <p:nvSpPr>
+          <p:cNvPr id="39" name="Rectangle 38"/>
+          <p:cNvSpPr/>
+          <p:nvPr/>
+        </p:nvSpPr>
+        <p:spPr>
+          <a:xfrm>
+            <a:off x="8072932" y="4315968"/>
+            <a:ext cx="41148" cy="1152144"/>
+          </a:xfrm>
+          <a:prstGeom prst="rect">
+            <a:avLst/>
+          </a:prstGeom>
+          <a:solidFill>
+            <a:srgbClr val="B45309"/>
+          </a:solidFill>
+          <a:ln>
+            <a:noFill/>
+          </a:ln>
+          <a:effectLst/>
+        </p:spPr>
+        <p:style>
+          <a:lnRef idx="1">
+            <a:schemeClr val="accent1"/>
+          </a:lnRef>
+          <a:fillRef idx="3">
+            <a:schemeClr val="accent1"/>
+          </a:fillRef>
+          <a:effectRef idx="2">
+            <a:schemeClr val="accent1"/>
+          </a:effectRef>
+          <a:fontRef idx="minor">
+            <a:schemeClr val="lt1"/>
+          </a:fontRef>
+        </p:style>
+        <p:txBody>
+          <a:bodyPr rtlCol="0" anchor="ctr"/>
+          <a:lstStyle/>
+          <a:p>
+            <a:pPr algn="ctr"/>
+          </a:p>
+        </p:txBody>
+      </p:sp>
+      <p:sp>
+        <p:nvSpPr>
+          <p:cNvPr id="40" name="TextBox 39"/>
+          <p:cNvSpPr txBox="1"/>
+          <p:nvPr/>
+        </p:nvSpPr>
+        <p:spPr>
+          <a:xfrm>
+            <a:off x="8328964" y="4334256"/>
+            <a:ext cx="3094634" cy="1152144"/>
+          </a:xfrm>
+          <a:prstGeom prst="rect">
+            <a:avLst/>
+          </a:prstGeom>
+          <a:noFill/>
+        </p:spPr>
+        <p:txBody>
+          <a:bodyPr wrap="square" lIns="0" rIns="0" tIns="0" bIns="0" anchor="t">
+            <a:spAutoFit/>
+          </a:bodyPr>
+          <a:lstStyle/>
+          <a:p>
+            <a:pPr algn="l">
+              <a:lnSpc>
+                <a:spcPct val="105000"/>
+              </a:lnSpc>
+              <a:spcBef>
+                <a:spcPts val="0"/>
+              </a:spcBef>
+              <a:spcAft>
+                <a:spcPts val="500"/>
+              </a:spcAft>
+            </a:pPr>
+            <a:r>
+              <a:rPr sz="1150" b="1" i="0">
+                <a:solidFill>
+                  <a:srgbClr val="1A2733"/>
+                </a:solidFill>
+                <a:latin typeface="Arial"/>
+              </a:rPr>
+              <a:t>No advertising, ever</a:t>
+            </a:r>
+          </a:p>
+          <a:p>
+            <a:pPr algn="l">
+              <a:lnSpc>
+                <a:spcPct val="122000"/>
+              </a:lnSpc>
+              <a:spcBef>
+                <a:spcPts val="0"/>
+              </a:spcBef>
+              <a:spcAft>
+                <a:spcPts val="0"/>
+              </a:spcAft>
+            </a:pPr>
+            <a:r>
+              <a:rPr sz="950" b="0" i="0">
+                <a:solidFill>
+                  <a:srgbClr val="3F4A57"/>
+                </a:solidFill>
+                <a:latin typeface="Arial"/>
+              </a:rPr>
+              <a:t>The DPDP Act 2023 forbids behavioural tracking and targeted advertising aimed at under-18s, and parental consent does not unlock it. Every user we have is 11 to 14. The usual way a free product pays for itself is closed, and we would not want it open.</a:t>
             </a:r>
           </a:p>
         </p:txBody>
@@ -39894,7 +40179,7 @@
                 </a:solidFill>
                 <a:latin typeface="Arial"/>
               </a:rPr>
-              <a:t>Learners never pay for the core learning loop. Institutions buy reach: NGOs, CSR programmes and government. The ₹450 floor is set by cost, not by ambition, because an active learner costs about ₹370 a year to serve, most of it AI inference. Full tiers and unit economics on slide 22.</a:t>
+              <a:t>Learners never pay for the core learning loop. Institutions buy reach: NGOs, CSR programmes and government. The ₹450 floor is set by cost, not by ambition, because an active learner costs about ₹370 a year to serve, most of it AI inference. Full tiers and unit economics on slide 24.</a:t>
             </a:r>
           </a:p>
         </p:txBody>

</xml_diff>

<commit_message>
feat(deck): slide 26, the demo
Four screens in the order a learner meets them, so the slide stands on
its own if the deck travels without the recording or the video will not
play. Nothing lives on the video only.

The close moves to 27.

Co-Authored-By: Claude Opus 5 <noreply@anthropic.com>
</commit_message>
<xml_diff>
--- a/docs/deck/Dagar-Pitch-Deck.pptx
+++ b/docs/deck/Dagar-Pitch-Deck.pptx
@@ -31,6 +31,7 @@
     <p:sldId id="279" r:id="rId31"/>
     <p:sldId id="280" r:id="rId32"/>
     <p:sldId id="281" r:id="rId33"/>
+    <p:sldId id="282" r:id="rId34"/>
   </p:sldIdLst>
   <p:sldSz cx="12191695" cy="6858000" type="screen4x3"/>
   <p:notesSz cx="6858000" cy="9144000"/>
@@ -3384,6 +3385,154 @@
 </file>
 
 <file path=ppt/notesSlides/notesSlide22.xml><?xml version="1.0" encoding="utf-8"?>
+<p:notes xmlns:a="http://schemas.openxmlformats.org/drawingml/2006/main" xmlns:p="http://schemas.openxmlformats.org/presentationml/2006/main" xmlns:r="http://schemas.openxmlformats.org/officeDocument/2006/relationships">
+  <p:cSld>
+    <p:spTree>
+      <p:nvGrpSpPr>
+        <p:cNvPr id="1" name=""/>
+        <p:cNvGrpSpPr/>
+        <p:nvPr/>
+      </p:nvGrpSpPr>
+      <p:grpSpPr>
+        <a:xfrm>
+          <a:off x="0" y="0"/>
+          <a:ext cx="0" cy="0"/>
+          <a:chOff x="0" y="0"/>
+          <a:chExt cx="0" cy="0"/>
+        </a:xfrm>
+      </p:grpSpPr>
+      <p:sp>
+        <p:nvSpPr>
+          <p:cNvPr id="2" name="Slide Image Placeholder 1"/>
+          <p:cNvSpPr>
+            <a:spLocks noGrp="1"/>
+          </p:cNvSpPr>
+          <p:nvPr>
+            <p:ph type="sldImg" idx="2"/>
+          </p:nvPr>
+        </p:nvSpPr>
+        <p:spPr/>
+      </p:sp>
+      <p:sp>
+        <p:nvSpPr>
+          <p:cNvPr id="3" name="Notes Placeholder 2"/>
+          <p:cNvSpPr>
+            <a:spLocks noGrp="1"/>
+          </p:cNvSpPr>
+          <p:nvPr>
+            <p:ph type="body" idx="3" sz="quarter"/>
+          </p:nvPr>
+        </p:nvSpPr>
+        <p:spPr/>
+        <p:txBody>
+          <a:bodyPr/>
+          <a:lstStyle/>
+          <a:p>
+            <a:r>
+              <a:t>IF THE VIDEO CANNOT BE PLAYED</a:t>
+            </a:r>
+          </a:p>
+          <a:p>
+            <a:r>
+              <a:t>This slide is the demo. Four screens in the order a learner meets them, and the</a:t>
+            </a:r>
+          </a:p>
+          <a:p>
+            <a:r>
+              <a:t>address to open it live. Nothing in the recording is on the video only.</a:t>
+            </a:r>
+          </a:p>
+          <a:p/>
+          <a:p>
+            <a:r>
+              <a:t>WHAT TO POINT AT WHILE IT PLAYS</a:t>
+            </a:r>
+          </a:p>
+          <a:p>
+            <a:r>
+              <a:t>The order, not the features. Lesson, then practice on the same concept while it</a:t>
+            </a:r>
+          </a:p>
+          <a:p>
+            <a:r>
+              <a:t>is still warm, then progress that the parent sees without an account. Every</a:t>
+            </a:r>
+          </a:p>
+          <a:p>
+            <a:r>
+              <a:t>competitor has lessons and quizzes. The sequence is the product.</a:t>
+            </a:r>
+          </a:p>
+          <a:p/>
+          <a:p>
+            <a:r>
+              <a:t>WHY THE VOICE IS SYNTHETIC</a:t>
+            </a:r>
+          </a:p>
+          <a:p>
+            <a:r>
+              <a:t>Two reasons and the second is the real one. It keeps the demo re-recordable</a:t>
+            </a:r>
+          </a:p>
+          <a:p>
+            <a:r>
+              <a:t>when the product changes, and it means the Hindi version exists at all rather</a:t>
+            </a:r>
+          </a:p>
+          <a:p>
+            <a:r>
+              <a:t>than waiting for someone to record it. The product's whole argument is that a</a:t>
+            </a:r>
+          </a:p>
+          <a:p>
+            <a:r>
+              <a:t>learner should not have to work in their second language to get help, and a</a:t>
+            </a:r>
+          </a:p>
+          <a:p>
+            <a:r>
+              <a:t>demo that is English-only would contradict that on the way out of the room.</a:t>
+            </a:r>
+          </a:p>
+          <a:p/>
+          <a:p>
+            <a:r>
+              <a:t>IF ASKED WHETHER IT IS A REAL RECORDING</a:t>
+            </a:r>
+          </a:p>
+          <a:p>
+            <a:r>
+              <a:t>Yes. It is the running app on a phone, not a prototype and not a mock-up. Only</a:t>
+            </a:r>
+          </a:p>
+          <a:p>
+            <a:r>
+              <a:t>the voice is generated.</a:t>
+            </a:r>
+          </a:p>
+        </p:txBody>
+      </p:sp>
+      <p:sp>
+        <p:nvSpPr>
+          <p:cNvPr id="4" name="Slide Number Placeholder 3"/>
+          <p:cNvSpPr>
+            <a:spLocks noGrp="1"/>
+          </p:cNvSpPr>
+          <p:nvPr>
+            <p:ph type="sldNum" idx="5" sz="quarter"/>
+          </p:nvPr>
+        </p:nvSpPr>
+        <p:spPr/>
+      </p:sp>
+    </p:spTree>
+  </p:cSld>
+  <p:clrMapOvr>
+    <a:masterClrMapping/>
+  </p:clrMapOvr>
+</p:notes>
+</file>
+
+<file path=ppt/notesSlides/notesSlide23.xml><?xml version="1.0" encoding="utf-8"?>
 <p:notes xmlns:a="http://schemas.openxmlformats.org/drawingml/2006/main" xmlns:p="http://schemas.openxmlformats.org/presentationml/2006/main" xmlns:r="http://schemas.openxmlformats.org/officeDocument/2006/relationships">
   <p:cSld>
     <p:spTree>
@@ -35532,7 +35681,882 @@
                 </a:solidFill>
                 <a:latin typeface="Arial"/>
               </a:rPr>
-              <a:t>26 · THE ASK</a:t>
+              <a:t>26 · DEMO</a:t>
+            </a:r>
+          </a:p>
+        </p:txBody>
+      </p:sp>
+      <p:sp>
+        <p:nvSpPr>
+          <p:cNvPr id="4" name="TextBox 3"/>
+          <p:cNvSpPr txBox="1"/>
+          <p:nvPr/>
+        </p:nvSpPr>
+        <p:spPr>
+          <a:xfrm>
+            <a:off x="566928" y="713232"/>
+            <a:ext cx="10692079" cy="566928"/>
+          </a:xfrm>
+          <a:prstGeom prst="rect">
+            <a:avLst/>
+          </a:prstGeom>
+          <a:noFill/>
+        </p:spPr>
+        <p:txBody>
+          <a:bodyPr wrap="square" lIns="0" rIns="0" tIns="0" bIns="0" anchor="t">
+            <a:spAutoFit/>
+          </a:bodyPr>
+          <a:lstStyle/>
+          <a:p>
+            <a:pPr algn="l">
+              <a:lnSpc>
+                <a:spcPct val="100000"/>
+              </a:lnSpc>
+              <a:spcBef>
+                <a:spcPts val="0"/>
+              </a:spcBef>
+              <a:spcAft>
+                <a:spcPts val="0"/>
+              </a:spcAft>
+            </a:pPr>
+            <a:r>
+              <a:rPr sz="2900" b="1" i="0">
+                <a:solidFill>
+                  <a:srgbClr val="1A2733"/>
+                </a:solidFill>
+                <a:latin typeface="Arial"/>
+              </a:rPr>
+              <a:t>Ninety seconds, one learner's evening.</a:t>
+            </a:r>
+          </a:p>
+        </p:txBody>
+      </p:sp>
+      <p:sp>
+        <p:nvSpPr>
+          <p:cNvPr id="5" name="TextBox 4"/>
+          <p:cNvSpPr txBox="1"/>
+          <p:nvPr/>
+        </p:nvSpPr>
+        <p:spPr>
+          <a:xfrm>
+            <a:off x="566928" y="1316736"/>
+            <a:ext cx="10692079" cy="329184"/>
+          </a:xfrm>
+          <a:prstGeom prst="rect">
+            <a:avLst/>
+          </a:prstGeom>
+          <a:noFill/>
+        </p:spPr>
+        <p:txBody>
+          <a:bodyPr wrap="square" lIns="0" rIns="0" tIns="0" bIns="0" anchor="t">
+            <a:spAutoFit/>
+          </a:bodyPr>
+          <a:lstStyle/>
+          <a:p>
+            <a:pPr algn="l">
+              <a:lnSpc>
+                <a:spcPct val="115000"/>
+              </a:lnSpc>
+              <a:spcBef>
+                <a:spcPts val="0"/>
+              </a:spcBef>
+              <a:spcAft>
+                <a:spcPts val="0"/>
+              </a:spcAft>
+            </a:pPr>
+            <a:r>
+              <a:rPr sz="1350" b="0" i="0">
+                <a:solidFill>
+                  <a:srgbClr val="5B6673"/>
+                </a:solidFill>
+                <a:latin typeface="Arial"/>
+              </a:rPr>
+              <a:t>The recording follows the loop end to end, narrated in English and in Hindi. Or open it yourself: dagar-ap19.vercel.app</a:t>
+            </a:r>
+          </a:p>
+        </p:txBody>
+      </p:sp>
+      <p:sp>
+        <p:nvSpPr>
+          <p:cNvPr id="6" name="TextBox 5"/>
+          <p:cNvSpPr txBox="1"/>
+          <p:nvPr/>
+        </p:nvSpPr>
+        <p:spPr>
+          <a:xfrm>
+            <a:off x="566928" y="6455664"/>
+            <a:ext cx="5486400" cy="219456"/>
+          </a:xfrm>
+          <a:prstGeom prst="rect">
+            <a:avLst/>
+          </a:prstGeom>
+          <a:noFill/>
+        </p:spPr>
+        <p:txBody>
+          <a:bodyPr wrap="square" lIns="0" rIns="0" tIns="0" bIns="0" anchor="t">
+            <a:spAutoFit/>
+          </a:bodyPr>
+          <a:lstStyle/>
+          <a:p>
+            <a:pPr algn="l">
+              <a:spcBef>
+                <a:spcPts val="0"/>
+              </a:spcBef>
+              <a:spcAft>
+                <a:spcPts val="0"/>
+              </a:spcAft>
+            </a:pPr>
+            <a:r>
+              <a:rPr sz="850" b="0" i="0">
+                <a:solidFill>
+                  <a:srgbClr val="5B6673"/>
+                </a:solidFill>
+                <a:latin typeface="Arial"/>
+              </a:rPr>
+              <a:t>Dagar  ·  A personal guide for every learner's journey</a:t>
+            </a:r>
+          </a:p>
+        </p:txBody>
+      </p:sp>
+      <p:sp>
+        <p:nvSpPr>
+          <p:cNvPr id="7" name="TextBox 6"/>
+          <p:cNvSpPr txBox="1"/>
+          <p:nvPr/>
+        </p:nvSpPr>
+        <p:spPr>
+          <a:xfrm>
+            <a:off x="9795967" y="6455664"/>
+            <a:ext cx="1828800" cy="219456"/>
+          </a:xfrm>
+          <a:prstGeom prst="rect">
+            <a:avLst/>
+          </a:prstGeom>
+          <a:noFill/>
+        </p:spPr>
+        <p:txBody>
+          <a:bodyPr wrap="square" lIns="0" rIns="0" tIns="0" bIns="0" anchor="t">
+            <a:spAutoFit/>
+          </a:bodyPr>
+          <a:lstStyle/>
+          <a:p>
+            <a:pPr algn="r">
+              <a:spcBef>
+                <a:spcPts val="0"/>
+              </a:spcBef>
+              <a:spcAft>
+                <a:spcPts val="0"/>
+              </a:spcAft>
+            </a:pPr>
+            <a:r>
+              <a:rPr sz="850" b="0" i="0">
+                <a:solidFill>
+                  <a:srgbClr val="5B6673"/>
+                </a:solidFill>
+                <a:latin typeface="Arial"/>
+              </a:rPr>
+              <a:t>26</a:t>
+            </a:r>
+          </a:p>
+        </p:txBody>
+      </p:sp>
+      <p:pic>
+        <p:nvPicPr>
+          <p:cNvPr id="8" name="Picture 7" descr="dashboard-en.png"/>
+          <p:cNvPicPr>
+            <a:picLocks noChangeAspect="1"/>
+          </p:cNvPicPr>
+          <p:nvPr/>
+        </p:nvPicPr>
+        <p:blipFill>
+          <a:blip r:embed="rId2"/>
+          <a:stretch>
+            <a:fillRect/>
+          </a:stretch>
+        </p:blipFill>
+        <p:spPr>
+          <a:xfrm>
+            <a:off x="1381748" y="1883664"/>
+            <a:ext cx="1134818" cy="2395728"/>
+          </a:xfrm>
+          <a:prstGeom prst="rect">
+            <a:avLst/>
+          </a:prstGeom>
+        </p:spPr>
+      </p:pic>
+      <p:sp>
+        <p:nvSpPr>
+          <p:cNvPr id="9" name="TextBox 8"/>
+          <p:cNvSpPr txBox="1"/>
+          <p:nvPr/>
+        </p:nvSpPr>
+        <p:spPr>
+          <a:xfrm>
+            <a:off x="658368" y="4389120"/>
+            <a:ext cx="2581579" cy="219456"/>
+          </a:xfrm>
+          <a:prstGeom prst="rect">
+            <a:avLst/>
+          </a:prstGeom>
+          <a:noFill/>
+        </p:spPr>
+        <p:txBody>
+          <a:bodyPr wrap="square" lIns="0" rIns="0" tIns="0" bIns="0" anchor="t">
+            <a:spAutoFit/>
+          </a:bodyPr>
+          <a:lstStyle/>
+          <a:p>
+            <a:pPr algn="l">
+              <a:spcBef>
+                <a:spcPts val="0"/>
+              </a:spcBef>
+              <a:spcAft>
+                <a:spcPts val="0"/>
+              </a:spcAft>
+            </a:pPr>
+            <a:r>
+              <a:rPr sz="1100" b="1" i="0">
+                <a:solidFill>
+                  <a:srgbClr val="1A2733"/>
+                </a:solidFill>
+                <a:latin typeface="Arial"/>
+              </a:rPr>
+              <a:t>1 · She opens it</a:t>
+            </a:r>
+          </a:p>
+        </p:txBody>
+      </p:sp>
+      <p:sp>
+        <p:nvSpPr>
+          <p:cNvPr id="10" name="TextBox 9"/>
+          <p:cNvSpPr txBox="1"/>
+          <p:nvPr/>
+        </p:nvSpPr>
+        <p:spPr>
+          <a:xfrm>
+            <a:off x="658368" y="4608576"/>
+            <a:ext cx="2581579" cy="548640"/>
+          </a:xfrm>
+          <a:prstGeom prst="rect">
+            <a:avLst/>
+          </a:prstGeom>
+          <a:noFill/>
+        </p:spPr>
+        <p:txBody>
+          <a:bodyPr wrap="square" lIns="0" rIns="0" tIns="0" bIns="0" anchor="t">
+            <a:spAutoFit/>
+          </a:bodyPr>
+          <a:lstStyle/>
+          <a:p>
+            <a:pPr algn="l">
+              <a:lnSpc>
+                <a:spcPct val="124000"/>
+              </a:lnSpc>
+              <a:spcBef>
+                <a:spcPts val="0"/>
+              </a:spcBef>
+              <a:spcAft>
+                <a:spcPts val="0"/>
+              </a:spcAft>
+            </a:pPr>
+            <a:r>
+              <a:rPr sz="900" b="0" i="0">
+                <a:solidFill>
+                  <a:srgbClr val="3F4A57"/>
+                </a:solidFill>
+                <a:latin typeface="Arial"/>
+              </a:rPr>
+              <a:t>One thing to do next, a streak, and a goal she can finish tonight.</a:t>
+            </a:r>
+          </a:p>
+        </p:txBody>
+      </p:sp>
+      <p:pic>
+        <p:nvPicPr>
+          <p:cNvPr id="11" name="Picture 10" descr="lesson-step.png"/>
+          <p:cNvPicPr>
+            <a:picLocks noChangeAspect="1"/>
+          </p:cNvPicPr>
+          <p:nvPr/>
+        </p:nvPicPr>
+        <p:blipFill>
+          <a:blip r:embed="rId3"/>
+          <a:stretch>
+            <a:fillRect/>
+          </a:stretch>
+        </p:blipFill>
+        <p:spPr>
+          <a:xfrm>
+            <a:off x="4146208" y="1883664"/>
+            <a:ext cx="1134818" cy="2395728"/>
+          </a:xfrm>
+          <a:prstGeom prst="rect">
+            <a:avLst/>
+          </a:prstGeom>
+        </p:spPr>
+      </p:pic>
+      <p:sp>
+        <p:nvSpPr>
+          <p:cNvPr id="12" name="TextBox 11"/>
+          <p:cNvSpPr txBox="1"/>
+          <p:nvPr/>
+        </p:nvSpPr>
+        <p:spPr>
+          <a:xfrm>
+            <a:off x="3422827" y="4389120"/>
+            <a:ext cx="2581579" cy="219456"/>
+          </a:xfrm>
+          <a:prstGeom prst="rect">
+            <a:avLst/>
+          </a:prstGeom>
+          <a:noFill/>
+        </p:spPr>
+        <p:txBody>
+          <a:bodyPr wrap="square" lIns="0" rIns="0" tIns="0" bIns="0" anchor="t">
+            <a:spAutoFit/>
+          </a:bodyPr>
+          <a:lstStyle/>
+          <a:p>
+            <a:pPr algn="l">
+              <a:spcBef>
+                <a:spcPts val="0"/>
+              </a:spcBef>
+              <a:spcAft>
+                <a:spcPts val="0"/>
+              </a:spcAft>
+            </a:pPr>
+            <a:r>
+              <a:rPr sz="1100" b="1" i="0">
+                <a:solidFill>
+                  <a:srgbClr val="1A2733"/>
+                </a:solidFill>
+                <a:latin typeface="Arial"/>
+              </a:rPr>
+              <a:t>2 · A lesson she answers</a:t>
+            </a:r>
+          </a:p>
+        </p:txBody>
+      </p:sp>
+      <p:sp>
+        <p:nvSpPr>
+          <p:cNvPr id="13" name="TextBox 12"/>
+          <p:cNvSpPr txBox="1"/>
+          <p:nvPr/>
+        </p:nvSpPr>
+        <p:spPr>
+          <a:xfrm>
+            <a:off x="3422827" y="4608576"/>
+            <a:ext cx="2581579" cy="548640"/>
+          </a:xfrm>
+          <a:prstGeom prst="rect">
+            <a:avLst/>
+          </a:prstGeom>
+          <a:noFill/>
+        </p:spPr>
+        <p:txBody>
+          <a:bodyPr wrap="square" lIns="0" rIns="0" tIns="0" bIns="0" anchor="t">
+            <a:spAutoFit/>
+          </a:bodyPr>
+          <a:lstStyle/>
+          <a:p>
+            <a:pPr algn="l">
+              <a:lnSpc>
+                <a:spcPct val="124000"/>
+              </a:lnSpc>
+              <a:spcBef>
+                <a:spcPts val="0"/>
+              </a:spcBef>
+              <a:spcAft>
+                <a:spcPts val="0"/>
+              </a:spcAft>
+            </a:pPr>
+            <a:r>
+              <a:rPr sz="900" b="0" i="0">
+                <a:solidFill>
+                  <a:srgbClr val="3F4A57"/>
+                </a:solidFill>
+                <a:latin typeface="Arial"/>
+              </a:rPr>
+              <a:t>One idea per screen, a real diagram, and a hint before any answer.</a:t>
+            </a:r>
+          </a:p>
+        </p:txBody>
+      </p:sp>
+      <p:pic>
+        <p:nvPicPr>
+          <p:cNvPr id="14" name="Picture 13" descr="practice-tiles.png"/>
+          <p:cNvPicPr>
+            <a:picLocks noChangeAspect="1"/>
+          </p:cNvPicPr>
+          <p:nvPr/>
+        </p:nvPicPr>
+        <p:blipFill>
+          <a:blip r:embed="rId4"/>
+          <a:stretch>
+            <a:fillRect/>
+          </a:stretch>
+        </p:blipFill>
+        <p:spPr>
+          <a:xfrm>
+            <a:off x="6910668" y="1883664"/>
+            <a:ext cx="1134818" cy="2395728"/>
+          </a:xfrm>
+          <a:prstGeom prst="rect">
+            <a:avLst/>
+          </a:prstGeom>
+        </p:spPr>
+      </p:pic>
+      <p:sp>
+        <p:nvSpPr>
+          <p:cNvPr id="15" name="TextBox 14"/>
+          <p:cNvSpPr txBox="1"/>
+          <p:nvPr/>
+        </p:nvSpPr>
+        <p:spPr>
+          <a:xfrm>
+            <a:off x="6187287" y="4389120"/>
+            <a:ext cx="2581579" cy="219456"/>
+          </a:xfrm>
+          <a:prstGeom prst="rect">
+            <a:avLst/>
+          </a:prstGeom>
+          <a:noFill/>
+        </p:spPr>
+        <p:txBody>
+          <a:bodyPr wrap="square" lIns="0" rIns="0" tIns="0" bIns="0" anchor="t">
+            <a:spAutoFit/>
+          </a:bodyPr>
+          <a:lstStyle/>
+          <a:p>
+            <a:pPr algn="l">
+              <a:spcBef>
+                <a:spcPts val="0"/>
+              </a:spcBef>
+              <a:spcAft>
+                <a:spcPts val="0"/>
+              </a:spcAft>
+            </a:pPr>
+            <a:r>
+              <a:rPr sz="1100" b="1" i="0">
+                <a:solidFill>
+                  <a:srgbClr val="1A2733"/>
+                </a:solidFill>
+                <a:latin typeface="Arial"/>
+              </a:rPr>
+              <a:t>3 · Practice while it is warm</a:t>
+            </a:r>
+          </a:p>
+        </p:txBody>
+      </p:sp>
+      <p:sp>
+        <p:nvSpPr>
+          <p:cNvPr id="16" name="TextBox 15"/>
+          <p:cNvSpPr txBox="1"/>
+          <p:nvPr/>
+        </p:nvSpPr>
+        <p:spPr>
+          <a:xfrm>
+            <a:off x="6187287" y="4608576"/>
+            <a:ext cx="2581579" cy="548640"/>
+          </a:xfrm>
+          <a:prstGeom prst="rect">
+            <a:avLst/>
+          </a:prstGeom>
+          <a:noFill/>
+        </p:spPr>
+        <p:txBody>
+          <a:bodyPr wrap="square" lIns="0" rIns="0" tIns="0" bIns="0" anchor="t">
+            <a:spAutoFit/>
+          </a:bodyPr>
+          <a:lstStyle/>
+          <a:p>
+            <a:pPr algn="l">
+              <a:lnSpc>
+                <a:spcPct val="124000"/>
+              </a:lnSpc>
+              <a:spcBef>
+                <a:spcPts val="0"/>
+              </a:spcBef>
+              <a:spcAft>
+                <a:spcPts val="0"/>
+              </a:spcAft>
+            </a:pPr>
+            <a:r>
+              <a:rPr sz="900" b="0" i="0">
+                <a:solidFill>
+                  <a:srgbClr val="3F4A57"/>
+                </a:solidFill>
+                <a:latin typeface="Arial"/>
+              </a:rPr>
+              <a:t>Graded by code, not by AI. Wrong is amber, and it comes with a way forward.</a:t>
+            </a:r>
+          </a:p>
+        </p:txBody>
+      </p:sp>
+      <p:pic>
+        <p:nvPicPr>
+          <p:cNvPr id="17" name="Picture 16" descr="progress-en.png"/>
+          <p:cNvPicPr>
+            <a:picLocks noChangeAspect="1"/>
+          </p:cNvPicPr>
+          <p:nvPr/>
+        </p:nvPicPr>
+        <p:blipFill>
+          <a:blip r:embed="rId5"/>
+          <a:stretch>
+            <a:fillRect/>
+          </a:stretch>
+        </p:blipFill>
+        <p:spPr>
+          <a:xfrm>
+            <a:off x="9675128" y="1883664"/>
+            <a:ext cx="1134818" cy="2395728"/>
+          </a:xfrm>
+          <a:prstGeom prst="rect">
+            <a:avLst/>
+          </a:prstGeom>
+        </p:spPr>
+      </p:pic>
+      <p:sp>
+        <p:nvSpPr>
+          <p:cNvPr id="18" name="TextBox 17"/>
+          <p:cNvSpPr txBox="1"/>
+          <p:nvPr/>
+        </p:nvSpPr>
+        <p:spPr>
+          <a:xfrm>
+            <a:off x="8951747" y="4389120"/>
+            <a:ext cx="2581579" cy="219456"/>
+          </a:xfrm>
+          <a:prstGeom prst="rect">
+            <a:avLst/>
+          </a:prstGeom>
+          <a:noFill/>
+        </p:spPr>
+        <p:txBody>
+          <a:bodyPr wrap="square" lIns="0" rIns="0" tIns="0" bIns="0" anchor="t">
+            <a:spAutoFit/>
+          </a:bodyPr>
+          <a:lstStyle/>
+          <a:p>
+            <a:pPr algn="l">
+              <a:spcBef>
+                <a:spcPts val="0"/>
+              </a:spcBef>
+              <a:spcAft>
+                <a:spcPts val="0"/>
+              </a:spcAft>
+            </a:pPr>
+            <a:r>
+              <a:rPr sz="1100" b="1" i="0">
+                <a:solidFill>
+                  <a:srgbClr val="1A2733"/>
+                </a:solidFill>
+                <a:latin typeface="Arial"/>
+              </a:rPr>
+              <a:t>4 · Progress she can see</a:t>
+            </a:r>
+          </a:p>
+        </p:txBody>
+      </p:sp>
+      <p:sp>
+        <p:nvSpPr>
+          <p:cNvPr id="19" name="TextBox 18"/>
+          <p:cNvSpPr txBox="1"/>
+          <p:nvPr/>
+        </p:nvSpPr>
+        <p:spPr>
+          <a:xfrm>
+            <a:off x="8951747" y="4608576"/>
+            <a:ext cx="2581579" cy="548640"/>
+          </a:xfrm>
+          <a:prstGeom prst="rect">
+            <a:avLst/>
+          </a:prstGeom>
+          <a:noFill/>
+        </p:spPr>
+        <p:txBody>
+          <a:bodyPr wrap="square" lIns="0" rIns="0" tIns="0" bIns="0" anchor="t">
+            <a:spAutoFit/>
+          </a:bodyPr>
+          <a:lstStyle/>
+          <a:p>
+            <a:pPr algn="l">
+              <a:lnSpc>
+                <a:spcPct val="124000"/>
+              </a:lnSpc>
+              <a:spcBef>
+                <a:spcPts val="0"/>
+              </a:spcBef>
+              <a:spcAft>
+                <a:spcPts val="0"/>
+              </a:spcAft>
+            </a:pPr>
+            <a:r>
+              <a:rPr sz="900" b="0" i="0">
+                <a:solidFill>
+                  <a:srgbClr val="3F4A57"/>
+                </a:solidFill>
+                <a:latin typeface="Arial"/>
+              </a:rPr>
+              <a:t>Mastery per concept, the week, and the same numbers her parent sees.</a:t>
+            </a:r>
+          </a:p>
+        </p:txBody>
+      </p:sp>
+      <p:sp>
+        <p:nvSpPr>
+          <p:cNvPr id="20" name="Rounded Rectangle 19"/>
+          <p:cNvSpPr/>
+          <p:nvPr/>
+        </p:nvSpPr>
+        <p:spPr>
+          <a:xfrm>
+            <a:off x="566928" y="5248656"/>
+            <a:ext cx="11057839" cy="713232"/>
+          </a:xfrm>
+          <a:prstGeom prst="roundRect">
+            <a:avLst>
+              <a:gd name="adj" fmla="val 6000"/>
+            </a:avLst>
+          </a:prstGeom>
+          <a:solidFill>
+            <a:srgbClr val="F1F5F4"/>
+          </a:solidFill>
+          <a:ln w="12700">
+            <a:solidFill>
+              <a:srgbClr val="D8DEE4"/>
+            </a:solidFill>
+          </a:ln>
+          <a:effectLst/>
+        </p:spPr>
+        <p:style>
+          <a:lnRef idx="1">
+            <a:schemeClr val="accent1"/>
+          </a:lnRef>
+          <a:fillRef idx="3">
+            <a:schemeClr val="accent1"/>
+          </a:fillRef>
+          <a:effectRef idx="2">
+            <a:schemeClr val="accent1"/>
+          </a:effectRef>
+          <a:fontRef idx="minor">
+            <a:schemeClr val="lt1"/>
+          </a:fontRef>
+        </p:style>
+        <p:txBody>
+          <a:bodyPr rtlCol="0" anchor="ctr"/>
+          <a:lstStyle/>
+          <a:p>
+            <a:pPr algn="ctr"/>
+          </a:p>
+        </p:txBody>
+      </p:sp>
+      <p:sp>
+        <p:nvSpPr>
+          <p:cNvPr id="21" name="Rectangle 20"/>
+          <p:cNvSpPr/>
+          <p:nvPr/>
+        </p:nvSpPr>
+        <p:spPr>
+          <a:xfrm>
+            <a:off x="566928" y="5385816"/>
+            <a:ext cx="54864" cy="438912"/>
+          </a:xfrm>
+          <a:prstGeom prst="rect">
+            <a:avLst/>
+          </a:prstGeom>
+          <a:solidFill>
+            <a:srgbClr val="B45309"/>
+          </a:solidFill>
+          <a:ln>
+            <a:noFill/>
+          </a:ln>
+          <a:effectLst/>
+        </p:spPr>
+        <p:style>
+          <a:lnRef idx="1">
+            <a:schemeClr val="accent1"/>
+          </a:lnRef>
+          <a:fillRef idx="3">
+            <a:schemeClr val="accent1"/>
+          </a:fillRef>
+          <a:effectRef idx="2">
+            <a:schemeClr val="accent1"/>
+          </a:effectRef>
+          <a:fontRef idx="minor">
+            <a:schemeClr val="lt1"/>
+          </a:fontRef>
+        </p:style>
+        <p:txBody>
+          <a:bodyPr rtlCol="0" anchor="ctr"/>
+          <a:lstStyle/>
+          <a:p>
+            <a:pPr algn="ctr"/>
+          </a:p>
+        </p:txBody>
+      </p:sp>
+      <p:sp>
+        <p:nvSpPr>
+          <p:cNvPr id="22" name="TextBox 21"/>
+          <p:cNvSpPr txBox="1"/>
+          <p:nvPr/>
+        </p:nvSpPr>
+        <p:spPr>
+          <a:xfrm>
+            <a:off x="877824" y="5358384"/>
+            <a:ext cx="10417759" cy="512064"/>
+          </a:xfrm>
+          <a:prstGeom prst="rect">
+            <a:avLst/>
+          </a:prstGeom>
+          <a:noFill/>
+        </p:spPr>
+        <p:txBody>
+          <a:bodyPr wrap="square" lIns="0" rIns="0" tIns="0" bIns="0" anchor="t">
+            <a:spAutoFit/>
+          </a:bodyPr>
+          <a:lstStyle/>
+          <a:p>
+            <a:pPr algn="l">
+              <a:spcBef>
+                <a:spcPts val="0"/>
+              </a:spcBef>
+              <a:spcAft>
+                <a:spcPts val="200"/>
+              </a:spcAft>
+            </a:pPr>
+            <a:r>
+              <a:rPr sz="1150" b="1" i="0">
+                <a:solidFill>
+                  <a:srgbClr val="1A2733"/>
+                </a:solidFill>
+                <a:latin typeface="Arial"/>
+              </a:rPr>
+              <a:t>The narration is synthetic, in both languages, on purpose.</a:t>
+            </a:r>
+          </a:p>
+          <a:p>
+            <a:pPr algn="l">
+              <a:spcBef>
+                <a:spcPts val="0"/>
+              </a:spcBef>
+              <a:spcAft>
+                <a:spcPts val="0"/>
+              </a:spcAft>
+            </a:pPr>
+            <a:r>
+              <a:rPr sz="950" b="0" i="0">
+                <a:solidFill>
+                  <a:srgbClr val="3F4A57"/>
+                </a:solidFill>
+                <a:latin typeface="Arial"/>
+              </a:rPr>
+              <a:t>A learner who reads in Hindi should be able to watch the demo in Hindi. It is the same argument the product makes.</a:t>
+            </a:r>
+          </a:p>
+        </p:txBody>
+      </p:sp>
+    </p:spTree>
+  </p:cSld>
+  <p:clrMapOvr>
+    <a:masterClrMapping/>
+  </p:clrMapOvr>
+</p:sld>
+</file>
+
+<file path=ppt/slides/slide27.xml><?xml version="1.0" encoding="utf-8"?>
+<p:sld xmlns:a="http://schemas.openxmlformats.org/drawingml/2006/main" xmlns:p="http://schemas.openxmlformats.org/presentationml/2006/main" xmlns:r="http://schemas.openxmlformats.org/officeDocument/2006/relationships">
+  <p:cSld>
+    <p:spTree>
+      <p:nvGrpSpPr>
+        <p:cNvPr id="1" name=""/>
+        <p:cNvGrpSpPr/>
+        <p:nvPr/>
+      </p:nvGrpSpPr>
+      <p:grpSpPr/>
+      <p:sp>
+        <p:nvSpPr>
+          <p:cNvPr id="2" name="Rectangle 1"/>
+          <p:cNvSpPr/>
+          <p:nvPr/>
+        </p:nvSpPr>
+        <p:spPr>
+          <a:xfrm>
+            <a:off x="566928" y="475488"/>
+            <a:ext cx="310896" cy="50292"/>
+          </a:xfrm>
+          <a:prstGeom prst="rect">
+            <a:avLst/>
+          </a:prstGeom>
+          <a:solidFill>
+            <a:srgbClr val="0F766E"/>
+          </a:solidFill>
+          <a:ln>
+            <a:noFill/>
+          </a:ln>
+          <a:effectLst/>
+        </p:spPr>
+        <p:style>
+          <a:lnRef idx="1">
+            <a:schemeClr val="accent1"/>
+          </a:lnRef>
+          <a:fillRef idx="3">
+            <a:schemeClr val="accent1"/>
+          </a:fillRef>
+          <a:effectRef idx="2">
+            <a:schemeClr val="accent1"/>
+          </a:effectRef>
+          <a:fontRef idx="minor">
+            <a:schemeClr val="lt1"/>
+          </a:fontRef>
+        </p:style>
+        <p:txBody>
+          <a:bodyPr rtlCol="0" anchor="ctr"/>
+          <a:lstStyle/>
+          <a:p>
+            <a:pPr algn="ctr"/>
+          </a:p>
+        </p:txBody>
+      </p:sp>
+      <p:sp>
+        <p:nvSpPr>
+          <p:cNvPr id="3" name="TextBox 2"/>
+          <p:cNvSpPr txBox="1"/>
+          <p:nvPr/>
+        </p:nvSpPr>
+        <p:spPr>
+          <a:xfrm>
+            <a:off x="987552" y="384048"/>
+            <a:ext cx="8229600" cy="274320"/>
+          </a:xfrm>
+          <a:prstGeom prst="rect">
+            <a:avLst/>
+          </a:prstGeom>
+          <a:noFill/>
+        </p:spPr>
+        <p:txBody>
+          <a:bodyPr wrap="square" lIns="0" rIns="0" tIns="0" bIns="0" anchor="t">
+            <a:spAutoFit/>
+          </a:bodyPr>
+          <a:lstStyle/>
+          <a:p>
+            <a:pPr algn="l">
+              <a:spcBef>
+                <a:spcPts val="0"/>
+              </a:spcBef>
+              <a:spcAft>
+                <a:spcPts val="0"/>
+              </a:spcAft>
+            </a:pPr>
+            <a:r>
+              <a:rPr sz="1050" b="1" i="0">
+                <a:solidFill>
+                  <a:srgbClr val="0F766E"/>
+                </a:solidFill>
+                <a:latin typeface="Arial"/>
+              </a:rPr>
+              <a:t>27 · THE ASK</a:t>
             </a:r>
           </a:p>
         </p:txBody>
@@ -36341,7 +37365,7 @@
                 </a:solidFill>
                 <a:latin typeface="Arial"/>
               </a:rPr>
-              <a:t>26</a:t>
+              <a:t>27</a:t>
             </a:r>
           </a:p>
         </p:txBody>

</xml_diff>

<commit_message>
feat(demo): serve the recordings from the app, and link the PDF at them
The deck is submitted as a single PDF, so links to files sitting beside
it break the moment it is uploaded on its own. Both recordings now live
in public/ and are served from the app's own domain, which means one
thing to keep alive rather than two.

Slide 26 prints both addresses in its closing band rather than hiding
them behind an annotation. A link that only exists as a PDF annotation
disappears in a printout, a screenshot, or a viewer that strips them,
and this file may arrive with nothing beside it. The PDF build lays a
clickable region over each half of the page on top of that.

Co-Authored-By: Claude Opus 5 <noreply@anthropic.com>
</commit_message>
<xml_diff>
--- a/docs/deck/Dagar-Pitch-Deck.pptx
+++ b/docs/deck/Dagar-Pitch-Deck.pptx
@@ -36312,8 +36312,8 @@
         </p:nvSpPr>
         <p:spPr>
           <a:xfrm>
-            <a:off x="566928" y="5248656"/>
-            <a:ext cx="11057839" cy="713232"/>
+            <a:off x="566928" y="5212079"/>
+            <a:ext cx="11057839" cy="786384"/>
           </a:xfrm>
           <a:prstGeom prst="roundRect">
             <a:avLst>
@@ -36360,8 +36360,8 @@
         </p:nvSpPr>
         <p:spPr>
           <a:xfrm>
-            <a:off x="566928" y="5385816"/>
-            <a:ext cx="54864" cy="438912"/>
+            <a:off x="566928" y="5349240"/>
+            <a:ext cx="54864" cy="512064"/>
           </a:xfrm>
           <a:prstGeom prst="rect">
             <a:avLst/>
@@ -36404,8 +36404,8 @@
         </p:nvSpPr>
         <p:spPr>
           <a:xfrm>
-            <a:off x="877824" y="5358384"/>
-            <a:ext cx="10417759" cy="512064"/>
+            <a:off x="877824" y="5330951"/>
+            <a:ext cx="5163159" cy="237744"/>
           </a:xfrm>
           <a:prstGeom prst="rect">
             <a:avLst/>
@@ -36423,19 +36423,168 @@
                 <a:spcPts val="0"/>
               </a:spcBef>
               <a:spcAft>
-                <a:spcPts val="200"/>
+                <a:spcPts val="0"/>
               </a:spcAft>
             </a:pPr>
             <a:r>
               <a:rPr sz="1150" b="1" i="0">
                 <a:solidFill>
-                  <a:srgbClr val="1A2733"/>
-                </a:solidFill>
-                <a:latin typeface="Arial"/>
-              </a:rPr>
-              <a:t>Short of time? Play it at 1.5x. The narration is synthetic, in both languages, on purpose.</a:t>
-            </a:r>
-          </a:p>
+                  <a:srgbClr val="0F766E"/>
+                </a:solidFill>
+                <a:latin typeface="Arial"/>
+              </a:rPr>
+              <a:t>Watch in English</a:t>
+            </a:r>
+          </a:p>
+        </p:txBody>
+      </p:sp>
+      <p:sp>
+        <p:nvSpPr>
+          <p:cNvPr id="23" name="TextBox 22"/>
+          <p:cNvSpPr txBox="1"/>
+          <p:nvPr/>
+        </p:nvSpPr>
+        <p:spPr>
+          <a:xfrm>
+            <a:off x="877824" y="5559551"/>
+            <a:ext cx="5163159" cy="219456"/>
+          </a:xfrm>
+          <a:prstGeom prst="rect">
+            <a:avLst/>
+          </a:prstGeom>
+          <a:noFill/>
+        </p:spPr>
+        <p:txBody>
+          <a:bodyPr wrap="square" lIns="0" rIns="0" tIns="0" bIns="0" anchor="t">
+            <a:spAutoFit/>
+          </a:bodyPr>
+          <a:lstStyle/>
+          <a:p>
+            <a:pPr algn="l">
+              <a:spcBef>
+                <a:spcPts val="0"/>
+              </a:spcBef>
+              <a:spcAft>
+                <a:spcPts val="0"/>
+              </a:spcAft>
+            </a:pPr>
+            <a:r>
+              <a:rPr sz="1000" b="0" i="0">
+                <a:solidFill>
+                  <a:srgbClr val="3F4A57"/>
+                </a:solidFill>
+                <a:latin typeface="Arial"/>
+              </a:rPr>
+              <a:t>dagar-ap19.vercel.app/demo-en.mp4</a:t>
+            </a:r>
+          </a:p>
+        </p:txBody>
+      </p:sp>
+      <p:sp>
+        <p:nvSpPr>
+          <p:cNvPr id="24" name="TextBox 23"/>
+          <p:cNvSpPr txBox="1"/>
+          <p:nvPr/>
+        </p:nvSpPr>
+        <p:spPr>
+          <a:xfrm>
+            <a:off x="6406743" y="5330951"/>
+            <a:ext cx="5163159" cy="237744"/>
+          </a:xfrm>
+          <a:prstGeom prst="rect">
+            <a:avLst/>
+          </a:prstGeom>
+          <a:noFill/>
+        </p:spPr>
+        <p:txBody>
+          <a:bodyPr wrap="square" lIns="0" rIns="0" tIns="0" bIns="0" anchor="t">
+            <a:spAutoFit/>
+          </a:bodyPr>
+          <a:lstStyle/>
+          <a:p>
+            <a:pPr algn="l">
+              <a:spcBef>
+                <a:spcPts val="0"/>
+              </a:spcBef>
+              <a:spcAft>
+                <a:spcPts val="0"/>
+              </a:spcAft>
+            </a:pPr>
+            <a:r>
+              <a:rPr sz="1150" b="1" i="0">
+                <a:solidFill>
+                  <a:srgbClr val="0F766E"/>
+                </a:solidFill>
+                <a:latin typeface="Arial"/>
+              </a:rPr>
+              <a:t>हिंदी में देखिए</a:t>
+            </a:r>
+          </a:p>
+        </p:txBody>
+      </p:sp>
+      <p:sp>
+        <p:nvSpPr>
+          <p:cNvPr id="25" name="TextBox 24"/>
+          <p:cNvSpPr txBox="1"/>
+          <p:nvPr/>
+        </p:nvSpPr>
+        <p:spPr>
+          <a:xfrm>
+            <a:off x="6406743" y="5559551"/>
+            <a:ext cx="5163159" cy="219456"/>
+          </a:xfrm>
+          <a:prstGeom prst="rect">
+            <a:avLst/>
+          </a:prstGeom>
+          <a:noFill/>
+        </p:spPr>
+        <p:txBody>
+          <a:bodyPr wrap="square" lIns="0" rIns="0" tIns="0" bIns="0" anchor="t">
+            <a:spAutoFit/>
+          </a:bodyPr>
+          <a:lstStyle/>
+          <a:p>
+            <a:pPr algn="l">
+              <a:spcBef>
+                <a:spcPts val="0"/>
+              </a:spcBef>
+              <a:spcAft>
+                <a:spcPts val="0"/>
+              </a:spcAft>
+            </a:pPr>
+            <a:r>
+              <a:rPr sz="1000" b="0" i="0">
+                <a:solidFill>
+                  <a:srgbClr val="3F4A57"/>
+                </a:solidFill>
+                <a:latin typeface="Arial"/>
+              </a:rPr>
+              <a:t>dagar-ap19.vercel.app/demo-hi.mp4</a:t>
+            </a:r>
+          </a:p>
+        </p:txBody>
+      </p:sp>
+      <p:sp>
+        <p:nvSpPr>
+          <p:cNvPr id="26" name="TextBox 25"/>
+          <p:cNvSpPr txBox="1"/>
+          <p:nvPr/>
+        </p:nvSpPr>
+        <p:spPr>
+          <a:xfrm>
+            <a:off x="877824" y="5760719"/>
+            <a:ext cx="10417759" cy="219456"/>
+          </a:xfrm>
+          <a:prstGeom prst="rect">
+            <a:avLst/>
+          </a:prstGeom>
+          <a:noFill/>
+        </p:spPr>
+        <p:txBody>
+          <a:bodyPr wrap="square" lIns="0" rIns="0" tIns="0" bIns="0" anchor="t">
+            <a:spAutoFit/>
+          </a:bodyPr>
+          <a:lstStyle/>
           <a:p>
             <a:pPr algn="l">
               <a:spcBef>
@@ -36448,11 +36597,11 @@
             <a:r>
               <a:rPr sz="950" b="0" i="0">
                 <a:solidFill>
-                  <a:srgbClr val="3F4A57"/>
-                </a:solidFill>
-                <a:latin typeface="Arial"/>
-              </a:rPr>
-              <a:t>It stays clear up to about 1.5x, and a learner who reads in Hindi should be able to watch the demo in Hindi. That is the same argument the product makes.</a:t>
+                  <a:srgbClr val="5B6673"/>
+                </a:solidFill>
+                <a:latin typeface="Arial"/>
+              </a:rPr>
+              <a:t>Short of time, play it at 1.5x. The narration is generated, in both languages, on purpose.</a:t>
             </a:r>
           </a:p>
         </p:txBody>

</xml_diff>

<commit_message>
fix(pricing): withdraw the one-to-one annual plan, reprice Plus annual
Both prices were inherited rather than decided, and both were wrong.

ONE TO ONE, annual withdrawn. ₹14,999 a year against ₹14,400 of teacher
time plus ₹370 of AI left ₹229 of margin for a whole year. The fix is not
a higher annual price, it is no annual price: the tier is capacity
constrained, and taking twelve months up front for teachers we have not
hired is a refund liability wearing revenue's clothes. Monthly keeps it
honest and lets it be repriced when real teacher costs are known.

PLUS, ₹799 to ₹999 a year. ₹799 was a 33% discount on the monthly price,
steep enough to make the monthly plan pointless. ₹999 is the standard two
months free, still comfortably inside what the segment can pay.

SOM revenue moves to ₹13.3 Cr, $1.51M ARR.

Docs in step: PRD §11 and MARKET_AND_PRICING §2.

Co-Authored-By: Claude Opus 5 <noreply@anthropic.com>
</commit_message>
<xml_diff>
--- a/docs/deck/Dagar-Pitch-Deck.pptx
+++ b/docs/deck/Dagar-Pitch-Deck.pptx
@@ -565,7 +565,7 @@
           </a:p>
           <a:p>
             <a:r>
-              <a:t>SOM   two segments, worked below, = ₹13 Cr, which is $1.48M ARR.</a:t>
+              <a:t>SOM   two segments, worked below, = ₹13.3 Cr, which is $1.51M ARR.</a:t>
             </a:r>
           </a:p>
           <a:p/>
@@ -652,7 +652,7 @@
           </a:p>
           <a:p>
             <a:r>
-              <a:t>                  Plus         60%   6,600 x ₹799     = ₹0.5 Cr</a:t>
+              <a:t>                  Plus         60%   6,600 x ₹999     = ₹0.7 Cr</a:t>
             </a:r>
           </a:p>
           <a:p>
@@ -662,18 +662,18 @@
           </a:p>
           <a:p>
             <a:r>
-              <a:t>                  One to one    5%     550 x ₹14,999  = ₹0.8 Cr</a:t>
-            </a:r>
-          </a:p>
-          <a:p>
-            <a:r>
-              <a:t>                  Free                264,000 x ₹0    = ₹0</a:t>
+              <a:t>                  One to one    5%     550 x ₹17,988   = ₹1.0 Cr</a:t>
+            </a:r>
+          </a:p>
+          <a:p>
+            <a:r>
+              <a:t>                  Free                264,000 x ₹0     = ₹0</a:t>
             </a:r>
           </a:p>
           <a:p/>
           <a:p>
             <a:r>
-              <a:t>  TOTAL           500,000 learners                    = ₹13 Cr, $1.48M ARR</a:t>
+              <a:t>  TOTAL           500,000 learners                     = ₹13.3 Cr, $1.51M ARR</a:t>
             </a:r>
           </a:p>
           <a:p/>
@@ -32235,7 +32235,7 @@
                 </a:solidFill>
                 <a:latin typeface="Arial"/>
               </a:rPr>
-              <a:t>Live, and two private sessions a month. Priced at what a teacher's hour actually costs. Gated on verified supply.</a:t>
+              <a:t>Live, and two private sessions a month. Priced at a teacher's real hourly cost. Monthly only: we will not take a year up front for teachers we have not hired.</a:t>
             </a:r>
           </a:p>
         </p:txBody>
@@ -41710,7 +41710,7 @@
                 </a:solidFill>
                 <a:latin typeface="Arial"/>
               </a:rPr>
-              <a:t>₹13 Cr  ·  $1.48M ARR</a:t>
+              <a:t>₹13.3 Cr  ·  $1.51M ARR</a:t>
             </a:r>
           </a:p>
         </p:txBody>

</xml_diff>